<commit_message>
Add editable customer conversation guides and shortlist exports
</commit_message>
<xml_diff>
--- a/docs/P1_edit/EV_Customer_Prioritization_Stakeholder_Presentation.pptx
+++ b/docs/P1_edit/EV_Customer_Prioritization_Stakeholder_Presentation.pptx
@@ -547,7 +547,7 @@
           <a:lstStyle xmlns:a="http://schemas.openxmlformats.org/drawingml/2006/main"/>
           <a:p xmlns:a="http://schemas.openxmlformats.org/drawingml/2006/main">
             <a:r>
-              <a:t>The tool accepts a CSV with the required schema. The demonstration template shows the exact column names and example categories. The output includes IDs, scores and recorded fields for review. This dataset does not supply names or contact details. The manager retains approval of any contact list. A score is an estimate of the supplied synthetic outcome label and requires real business validation.</a:t>
+              <a:t>Guides are draft conversation support based on recorded profile fields. Staff can edit a selected guide and download its TXT file. A bulk CSV contains guides for the current top-K shortlist, with a maximum of 1,000 profiles per batch. Staff verify facts and approve any contact. The app does not send messages or call customers. Ranking scores stay unchanged. Actual business outcomes still require a reviewed pilot.</a:t>
             </a:r>
           </a:p>
           <a:p xmlns:a="http://schemas.openxmlformats.org/drawingml/2006/main">
@@ -562,22 +562,22 @@
           </a:p>
           <a:p xmlns:a="http://schemas.openxmlformats.org/drawingml/2006/main">
             <a:r>
-              <a:t>data/demo/customer_profiles_template.csv</a:t>
-            </a:r>
-          </a:p>
-          <a:p xmlns:a="http://schemas.openxmlformats.org/drawingml/2006/main">
-            <a:r>
-              <a:t>ev_project/schema.py</a:t>
-            </a:r>
-          </a:p>
-          <a:p xmlns:a="http://schemas.openxmlformats.org/drawingml/2006/main">
-            <a:r>
               <a:t>app.py</a:t>
             </a:r>
           </a:p>
           <a:p xmlns:a="http://schemas.openxmlformats.org/drawingml/2006/main">
             <a:r>
-              <a:t>docs/reports/tables/data_dictionary.csv</a:t>
+              <a:t>ev_project/customer_details.py</a:t>
+            </a:r>
+          </a:p>
+          <a:p xmlns:a="http://schemas.openxmlformats.org/drawingml/2006/main">
+            <a:r>
+              <a:t>ev_project/conversation_guide.py</a:t>
+            </a:r>
+          </a:p>
+          <a:p xmlns:a="http://schemas.openxmlformats.org/drawingml/2006/main">
+            <a:r>
+              <a:t>Updated Customer Conversation Guide workflow and export controls.</a:t>
             </a:r>
           </a:p>
         </p:txBody>
@@ -937,7 +937,7 @@
           <a:lstStyle xmlns:a="http://schemas.openxmlformats.org/drawingml/2006/main"/>
           <a:p xmlns:a="http://schemas.openxmlformats.org/drawingml/2006/main">
             <a:r>
-              <a:t>The prototype already supports a CSV upload, a chosen list size, ranked results, recorded profile details and CSV downloads. Input checks provide feedback on missing fields and unsupported values. The score estimates the supplied synthetic Yes label. Staff should confirm the recorded information and decide whether contact is appropriate.</a:t>
+              <a:t>The Customer Conversation Guide starts after the manager creates a ranked shortlist and selects a customer. It provides an opening, questions about needs, discussion topics, concerns to explore and an optional appointment or test drive. Staff can edit the selected guide. They can download that script as a TXT file or export guides for the current top-K shortlist as a CSV, up to 1,000 profiles per batch. The guide uses recorded commute, charging context, range concerns and the current vehicle. Staff must verify those details. The ranking score stays unchanged and the app does not contact customers.</a:t>
             </a:r>
           </a:p>
           <a:p xmlns:a="http://schemas.openxmlformats.org/drawingml/2006/main">
@@ -957,17 +957,17 @@
           </a:p>
           <a:p xmlns:a="http://schemas.openxmlformats.org/drawingml/2006/main">
             <a:r>
-              <a:t>ev_project/scoring.py</a:t>
-            </a:r>
-          </a:p>
-          <a:p xmlns:a="http://schemas.openxmlformats.org/drawingml/2006/main">
-            <a:r>
               <a:t>ev_project/customer_details.py</a:t>
             </a:r>
           </a:p>
           <a:p xmlns:a="http://schemas.openxmlformats.org/drawingml/2006/main">
             <a:r>
-              <a:t>data/demo/customer_profiles_template.csv</a:t>
+              <a:t>ev_project/conversation_guide.py</a:t>
+            </a:r>
+          </a:p>
+          <a:p xmlns:a="http://schemas.openxmlformats.org/drawingml/2006/main">
+            <a:r>
+              <a:t>Conversation guide implementation and bulk guide export in the updated application.</a:t>
             </a:r>
           </a:p>
         </p:txBody>
@@ -1037,7 +1037,7 @@
           <a:lstStyle xmlns:a="http://schemas.openxmlformats.org/drawingml/2006/main"/>
           <a:p xmlns:a="http://schemas.openxmlformats.org/drawingml/2006/main">
             <a:r>
-              <a:t>This is an existing capture of the working prototype, showing a synthetic profile. It displays the customer ID, recorded fields and prompts that help staff confirm the context. A recorded demographic or income value does not establish preference, affordability or a suitable vehicle. The current app source provides the implementation details.</a:t>
+              <a:t>The real app capture shows the Customer Conversation Guide for a synthetic selected profile. Staff can check the recorded context, edit the draft and prepare a suitable conversation. The guide does not invent offers, pricing, savings or subsidy eligibility. Recorded demographic details do not determine the suggested questions. Staff should verify the customer’s situation before using the script. The guide supports preparation and does not establish a purchase outcome.</a:t>
             </a:r>
           </a:p>
           <a:p xmlns:a="http://schemas.openxmlformats.org/drawingml/2006/main">
@@ -1062,7 +1062,12 @@
           </a:p>
           <a:p xmlns:a="http://schemas.openxmlformats.org/drawingml/2006/main">
             <a:r>
-              <a:t>Existing real prototype screenshot: work/customer_profile_enhancement/customer_card.jpg</a:t>
+              <a:t>ev_project/conversation_guide.py</a:t>
+            </a:r>
+          </a:p>
+          <a:p xmlns:a="http://schemas.openxmlformats.org/drawingml/2006/main">
+            <a:r>
+              <a:t>Actual updated application screenshot: /Users/nguyenchau/Documents/Codex/2026-10-07/https-www-kaggle-com-competitions-playground/work/conversation_update_oct27/customer_conversation_guide.jpg</a:t>
             </a:r>
           </a:p>
         </p:txBody>
@@ -1312,7 +1317,7 @@
           <a:lstStyle xmlns:a="http://schemas.openxmlformats.org/drawingml/2006/main"/>
           <a:p xmlns:a="http://schemas.openxmlformats.org/drawingml/2006/main">
             <a:r>
-              <a:t>The diagram uses native editable flowchart symbols and attached directional connectors. The working technical flow includes profile data, checks, learning from the labeled data, evaluation, scoring and a manager’s review. CSV export supports the handoff for review. Contacting customers and capturing actual outcomes are planned pilot activities. The dashed return arrow shows that planned feedback would support future data checks and review before updates. Staff should review any updates based on that feedback before wider use.</a:t>
+              <a:t>The diagram uses native editable flowchart symbols and attached directional connectors. The working technical flow includes profile data, checks, learning from the labeled data, evaluation, scoring and a manager’s review. The shortlist and conversation-guide downloads support the handoff for staff review. Staff can edit a selected guide, download its TXT script, or export guides for the current shortlist as CSV. Contacting customers and capturing actual outcomes are planned pilot activities. The dashed return arrow shows that planned feedback would support future data checks and review before updates. Staff should review any updates based on that feedback before wider use.</a:t>
             </a:r>
           </a:p>
           <a:p xmlns:a="http://schemas.openxmlformats.org/drawingml/2006/main">
@@ -2788,6 +2793,7 @@
               </a:defRPr>
             </a:defPPr>
             <a:lvl1pPr>
+              <a:buNone/>
               <a:defRPr sz="3300" b="1">
                 <a:solidFill>
                   <a:srgbClr val="102C32"/>
@@ -2798,6 +2804,7 @@
               </a:defRPr>
             </a:lvl1pPr>
             <a:lvl2pPr>
+              <a:buNone/>
               <a:defRPr sz="3300" b="1">
                 <a:solidFill>
                   <a:srgbClr val="102C32"/>
@@ -2808,6 +2815,7 @@
               </a:defRPr>
             </a:lvl2pPr>
             <a:lvl3pPr>
+              <a:buNone/>
               <a:defRPr sz="3300" b="1">
                 <a:solidFill>
                   <a:srgbClr val="102C32"/>
@@ -2818,6 +2826,7 @@
               </a:defRPr>
             </a:lvl3pPr>
             <a:lvl4pPr>
+              <a:buNone/>
               <a:defRPr sz="3300" b="1">
                 <a:solidFill>
                   <a:srgbClr val="102C32"/>
@@ -2828,6 +2837,7 @@
               </a:defRPr>
             </a:lvl4pPr>
             <a:lvl5pPr>
+              <a:buNone/>
               <a:defRPr sz="3300" b="1">
                 <a:solidFill>
                   <a:srgbClr val="102C32"/>
@@ -2838,6 +2848,7 @@
               </a:defRPr>
             </a:lvl5pPr>
             <a:lvl6pPr>
+              <a:buNone/>
               <a:defRPr sz="3300" b="1">
                 <a:solidFill>
                   <a:srgbClr val="102C32"/>
@@ -2848,6 +2859,7 @@
               </a:defRPr>
             </a:lvl6pPr>
             <a:lvl7pPr>
+              <a:buNone/>
               <a:defRPr sz="3300" b="1">
                 <a:solidFill>
                   <a:srgbClr val="102C32"/>
@@ -2858,6 +2870,7 @@
               </a:defRPr>
             </a:lvl7pPr>
             <a:lvl8pPr>
+              <a:buNone/>
               <a:defRPr sz="3300" b="1">
                 <a:solidFill>
                   <a:srgbClr val="102C32"/>
@@ -2868,6 +2881,7 @@
               </a:defRPr>
             </a:lvl8pPr>
             <a:lvl9pPr>
+              <a:buNone/>
               <a:defRPr sz="3300" b="1">
                 <a:solidFill>
                   <a:srgbClr val="102C32"/>
@@ -2899,7 +2913,7 @@
                 <a:ea typeface="Arial"/>
                 <a:cs typeface="Arial"/>
               </a:rPr>
-              <a:t>Discussion: using the shortlist</a:t>
+              <a:t>Discussion: conversation guides</a:t>
             </a:r>
           </a:p>
         </p:txBody>
@@ -3025,7 +3039,7 @@
           <p:cNvPr id="7" name="">
             <a:extLst xmlns:a="http://schemas.openxmlformats.org/drawingml/2006/main">
               <a:ext uri="{FF2B5EF4-FFF2-40B4-BE49-F238E27FC236}">
-                <a16:creationId xmlns:a16="http://schemas.microsoft.com/office/drawing/2014/main" id="{4115773C-541F-470C-BAD0-FA02D1095BCF}"/>
+                <a16:creationId xmlns:a16="http://schemas.microsoft.com/office/drawing/2014/main" id="{DFD0D920-9A43-406D-B602-D9AF2C0B8DB4}"/>
               </a:ext>
             </a:extLst>
           </p:cNvPr>
@@ -3151,7 +3165,7 @@
                           <a:ea typeface="Arial"/>
                           <a:cs typeface="Arial"/>
                         </a:rPr>
-                        <a:t>What file does it accept?</a:t>
+                        <a:t>How does the guide use a profile?</a:t>
                       </a:r>
                     </a:p>
                   </a:txBody>
@@ -3193,7 +3207,7 @@
                           <a:ea typeface="Arial"/>
                           <a:cs typeface="Arial"/>
                         </a:rPr>
-                        <a:t>A CSV with an ID and 13 required profile fields.</a:t>
+                        <a:t>Draft sections use recorded travel, charging, range</a:t>
                       </a:r>
                     </a:p>
                     <a:p>
@@ -3206,7 +3220,7 @@
                           <a:ea typeface="Arial"/>
                           <a:cs typeface="Arial"/>
                         </a:rPr>
-                        <a:t>The downloadable template provides column names.</a:t>
+                        <a:t>concerns and current vehicle. Staff confirm the details.</a:t>
                       </a:r>
                     </a:p>
                   </a:txBody>
@@ -3244,7 +3258,7 @@
                           <a:ea typeface="Arial"/>
                           <a:cs typeface="Arial"/>
                         </a:rPr>
-                        <a:t>Does it include contact details?</a:t>
+                        <a:t>Can staff edit the guide?</a:t>
                       </a:r>
                     </a:p>
                   </a:txBody>
@@ -3286,7 +3300,7 @@
                           <a:ea typeface="Arial"/>
                           <a:cs typeface="Arial"/>
                         </a:rPr>
-                        <a:t>The dataset contains IDs and recorded fields.</a:t>
+                        <a:t>The selected guide is editable. Staff verify facts and</a:t>
                       </a:r>
                     </a:p>
                     <a:p>
@@ -3299,7 +3313,7 @@
                           <a:ea typeface="Arial"/>
                           <a:cs typeface="Arial"/>
                         </a:rPr>
-                        <a:t>It supplies no names, email addresses or phone numbers.</a:t>
+                        <a:t>approve any contact. The app sends no messages.</a:t>
                       </a:r>
                     </a:p>
                   </a:txBody>
@@ -3337,7 +3351,7 @@
                           <a:ea typeface="Arial"/>
                           <a:cs typeface="Arial"/>
                         </a:rPr>
-                        <a:t>Who approves a contact list?</a:t>
+                        <a:t>What can staff download?</a:t>
                       </a:r>
                     </a:p>
                   </a:txBody>
@@ -3379,7 +3393,7 @@
                           <a:ea typeface="Arial"/>
                           <a:cs typeface="Arial"/>
                         </a:rPr>
-                        <a:t>The manager reviews selected profiles and</a:t>
+                        <a:t>A selected script as TXT, or guides for the current</a:t>
                       </a:r>
                     </a:p>
                     <a:p>
@@ -3392,7 +3406,7 @@
                           <a:ea typeface="Arial"/>
                           <a:cs typeface="Arial"/>
                         </a:rPr>
-                        <a:t>confirms whether contact is appropriate.</a:t>
+                        <a:t>shortlist as CSV, up to 1,000 profiles per batch.</a:t>
                       </a:r>
                     </a:p>
                   </a:txBody>
@@ -3430,7 +3444,7 @@
                           <a:ea typeface="Arial"/>
                           <a:cs typeface="Arial"/>
                         </a:rPr>
-                        <a:t>What does a score mean?</a:t>
+                        <a:t>Does this change the ranking?</a:t>
                       </a:r>
                     </a:p>
                   </a:txBody>
@@ -3472,7 +3486,7 @@
                           <a:ea typeface="Arial"/>
                           <a:cs typeface="Arial"/>
                         </a:rPr>
-                        <a:t>An estimate of the supplied synthetic Yes label.</a:t>
+                        <a:t>Ranking scores stay the same. The guides support</a:t>
                       </a:r>
                     </a:p>
                     <a:p>
@@ -3485,7 +3499,7 @@
                           <a:ea typeface="Arial"/>
                           <a:cs typeface="Arial"/>
                         </a:rPr>
-                        <a:t>Actual business outcomes need a separate pilot.</a:t>
+                        <a:t>staff preparation. Actual sales outcomes need a pilot.</a:t>
                       </a:r>
                     </a:p>
                   </a:txBody>
@@ -7794,6 +7808,7 @@
               </a:defRPr>
             </a:defPPr>
             <a:lvl1pPr>
+              <a:buNone/>
               <a:defRPr sz="3300" b="1">
                 <a:solidFill>
                   <a:srgbClr val="102C32"/>
@@ -7804,6 +7819,7 @@
               </a:defRPr>
             </a:lvl1pPr>
             <a:lvl2pPr>
+              <a:buNone/>
               <a:defRPr sz="3300" b="1">
                 <a:solidFill>
                   <a:srgbClr val="102C32"/>
@@ -7814,6 +7830,7 @@
               </a:defRPr>
             </a:lvl2pPr>
             <a:lvl3pPr>
+              <a:buNone/>
               <a:defRPr sz="3300" b="1">
                 <a:solidFill>
                   <a:srgbClr val="102C32"/>
@@ -7824,6 +7841,7 @@
               </a:defRPr>
             </a:lvl3pPr>
             <a:lvl4pPr>
+              <a:buNone/>
               <a:defRPr sz="3300" b="1">
                 <a:solidFill>
                   <a:srgbClr val="102C32"/>
@@ -7834,6 +7852,7 @@
               </a:defRPr>
             </a:lvl4pPr>
             <a:lvl5pPr>
+              <a:buNone/>
               <a:defRPr sz="3300" b="1">
                 <a:solidFill>
                   <a:srgbClr val="102C32"/>
@@ -7844,6 +7863,7 @@
               </a:defRPr>
             </a:lvl5pPr>
             <a:lvl6pPr>
+              <a:buNone/>
               <a:defRPr sz="3300" b="1">
                 <a:solidFill>
                   <a:srgbClr val="102C32"/>
@@ -7854,6 +7874,7 @@
               </a:defRPr>
             </a:lvl6pPr>
             <a:lvl7pPr>
+              <a:buNone/>
               <a:defRPr sz="3300" b="1">
                 <a:solidFill>
                   <a:srgbClr val="102C32"/>
@@ -7864,6 +7885,7 @@
               </a:defRPr>
             </a:lvl7pPr>
             <a:lvl8pPr>
+              <a:buNone/>
               <a:defRPr sz="3300" b="1">
                 <a:solidFill>
                   <a:srgbClr val="102C32"/>
@@ -7874,6 +7896,7 @@
               </a:defRPr>
             </a:lvl8pPr>
             <a:lvl9pPr>
+              <a:buNone/>
               <a:defRPr sz="3300" b="1">
                 <a:solidFill>
                   <a:srgbClr val="102C32"/>
@@ -7905,7 +7928,7 @@
                 <a:ea typeface="Arial"/>
                 <a:cs typeface="Arial"/>
               </a:rPr>
-              <a:t>A working browser tool</a:t>
+              <a:t>Customer Conversation Guide</a:t>
             </a:r>
           </a:p>
         </p:txBody>
@@ -8028,10 +8051,10 @@
       </p:sp>
       <p:sp>
         <p:nvSpPr>
-          <p:cNvPr id="11" name="A manager controls the review list">
+          <p:cNvPr id="11" name="A draft for staff to review and edit">
             <a:extLst xmlns:a="http://schemas.openxmlformats.org/drawingml/2006/main">
               <a:ext uri="{FF2B5EF4-FFF2-40B4-BE49-F238E27FC236}">
-                <a16:creationId xmlns:a16="http://schemas.microsoft.com/office/drawing/2014/main" id="{34DDBD77-FBE0-460F-8837-AD57EC87755F}"/>
+                <a16:creationId xmlns:a16="http://schemas.microsoft.com/office/drawing/2014/main" id="{86307000-0DB2-4A07-B00E-E2E5A99D14BB}"/>
               </a:ext>
             </a:extLst>
           </p:cNvPr>
@@ -8043,7 +8066,7 @@
         <p:spPr>
           <a:xfrm xmlns:a="http://schemas.openxmlformats.org/drawingml/2006/main">
             <a:off x="609600" y="1371600"/>
-            <a:ext cx="10668000" cy="428625"/>
+            <a:ext cx="10972800" cy="428625"/>
           </a:xfrm>
           <a:prstGeom xmlns:a="http://schemas.openxmlformats.org/drawingml/2006/main" prst="rect">
             <a:avLst/>
@@ -8058,7 +8081,7 @@
             <a:noAutofit/>
           </a:bodyPr>
           <a:lstStyle xmlns:a="http://schemas.openxmlformats.org/drawingml/2006/main">
-            <a:defPPr algn="l">
+            <a:defPPr>
               <a:defRPr sz="2325" b="1">
                 <a:solidFill>
                   <a:srgbClr val="15866C"/>
@@ -8068,7 +8091,7 @@
                 <a:cs typeface="Arial"/>
               </a:defRPr>
             </a:defPPr>
-            <a:lvl1pPr algn="l">
+            <a:lvl1pPr>
               <a:defRPr sz="2325" b="1">
                 <a:solidFill>
                   <a:srgbClr val="15866C"/>
@@ -8078,7 +8101,7 @@
                 <a:cs typeface="Arial"/>
               </a:defRPr>
             </a:lvl1pPr>
-            <a:lvl2pPr algn="l">
+            <a:lvl2pPr>
               <a:defRPr sz="2325" b="1">
                 <a:solidFill>
                   <a:srgbClr val="15866C"/>
@@ -8088,7 +8111,7 @@
                 <a:cs typeface="Arial"/>
               </a:defRPr>
             </a:lvl2pPr>
-            <a:lvl3pPr algn="l">
+            <a:lvl3pPr>
               <a:defRPr sz="2325" b="1">
                 <a:solidFill>
                   <a:srgbClr val="15866C"/>
@@ -8098,7 +8121,7 @@
                 <a:cs typeface="Arial"/>
               </a:defRPr>
             </a:lvl3pPr>
-            <a:lvl4pPr algn="l">
+            <a:lvl4pPr>
               <a:defRPr sz="2325" b="1">
                 <a:solidFill>
                   <a:srgbClr val="15866C"/>
@@ -8108,7 +8131,7 @@
                 <a:cs typeface="Arial"/>
               </a:defRPr>
             </a:lvl4pPr>
-            <a:lvl5pPr algn="l">
+            <a:lvl5pPr>
               <a:defRPr sz="2325" b="1">
                 <a:solidFill>
                   <a:srgbClr val="15866C"/>
@@ -8118,7 +8141,7 @@
                 <a:cs typeface="Arial"/>
               </a:defRPr>
             </a:lvl5pPr>
-            <a:lvl6pPr algn="l">
+            <a:lvl6pPr>
               <a:defRPr sz="2325" b="1">
                 <a:solidFill>
                   <a:srgbClr val="15866C"/>
@@ -8128,7 +8151,7 @@
                 <a:cs typeface="Arial"/>
               </a:defRPr>
             </a:lvl6pPr>
-            <a:lvl7pPr algn="l">
+            <a:lvl7pPr>
               <a:defRPr sz="2325" b="1">
                 <a:solidFill>
                   <a:srgbClr val="15866C"/>
@@ -8138,7 +8161,7 @@
                 <a:cs typeface="Arial"/>
               </a:defRPr>
             </a:lvl7pPr>
-            <a:lvl8pPr algn="l">
+            <a:lvl8pPr>
               <a:defRPr sz="2325" b="1">
                 <a:solidFill>
                   <a:srgbClr val="15866C"/>
@@ -8148,7 +8171,7 @@
                 <a:cs typeface="Arial"/>
               </a:defRPr>
             </a:lvl8pPr>
-            <a:lvl9pPr algn="l">
+            <a:lvl9pPr>
               <a:defRPr sz="2325" b="1">
                 <a:solidFill>
                   <a:srgbClr val="15866C"/>
@@ -8160,7 +8183,7 @@
             </a:lvl9pPr>
           </a:lstStyle>
           <a:p xmlns:a="http://schemas.openxmlformats.org/drawingml/2006/main">
-            <a:pPr algn="l">
+            <a:pPr>
               <a:defRPr sz="2325" b="1">
                 <a:solidFill>
                   <a:srgbClr val="15866C"/>
@@ -8179,7 +8202,7 @@
                 <a:ea typeface="Arial"/>
                 <a:cs typeface="Arial"/>
               </a:rPr>
-              <a:t>A manager controls the review list</a:t>
+              <a:t>A draft for staff to review and edit</a:t>
             </a:r>
           </a:p>
         </p:txBody>
@@ -8189,7 +8212,7 @@
           <p:cNvPr id="12" name="1">
             <a:extLst xmlns:a="http://schemas.openxmlformats.org/drawingml/2006/main">
               <a:ext uri="{FF2B5EF4-FFF2-40B4-BE49-F238E27FC236}">
-                <a16:creationId xmlns:a16="http://schemas.microsoft.com/office/drawing/2014/main" id="{D059B3FA-8952-43CC-9931-281F529E6066}"/>
+                <a16:creationId xmlns:a16="http://schemas.microsoft.com/office/drawing/2014/main" id="{60BEF635-CACC-47E8-BF0C-C6A595A155AB}"/>
               </a:ext>
             </a:extLst>
           </p:cNvPr>
@@ -8216,7 +8239,7 @@
             <a:noAutofit/>
           </a:bodyPr>
           <a:lstStyle xmlns:a="http://schemas.openxmlformats.org/drawingml/2006/main">
-            <a:defPPr algn="l">
+            <a:defPPr>
               <a:defRPr sz="2700" b="1">
                 <a:solidFill>
                   <a:srgbClr val="15866C"/>
@@ -8226,7 +8249,7 @@
                 <a:cs typeface="Arial"/>
               </a:defRPr>
             </a:defPPr>
-            <a:lvl1pPr algn="l">
+            <a:lvl1pPr>
               <a:defRPr sz="2700" b="1">
                 <a:solidFill>
                   <a:srgbClr val="15866C"/>
@@ -8236,7 +8259,7 @@
                 <a:cs typeface="Arial"/>
               </a:defRPr>
             </a:lvl1pPr>
-            <a:lvl2pPr algn="l">
+            <a:lvl2pPr>
               <a:defRPr sz="2700" b="1">
                 <a:solidFill>
                   <a:srgbClr val="15866C"/>
@@ -8246,7 +8269,7 @@
                 <a:cs typeface="Arial"/>
               </a:defRPr>
             </a:lvl2pPr>
-            <a:lvl3pPr algn="l">
+            <a:lvl3pPr>
               <a:defRPr sz="2700" b="1">
                 <a:solidFill>
                   <a:srgbClr val="15866C"/>
@@ -8256,7 +8279,7 @@
                 <a:cs typeface="Arial"/>
               </a:defRPr>
             </a:lvl3pPr>
-            <a:lvl4pPr algn="l">
+            <a:lvl4pPr>
               <a:defRPr sz="2700" b="1">
                 <a:solidFill>
                   <a:srgbClr val="15866C"/>
@@ -8266,7 +8289,7 @@
                 <a:cs typeface="Arial"/>
               </a:defRPr>
             </a:lvl4pPr>
-            <a:lvl5pPr algn="l">
+            <a:lvl5pPr>
               <a:defRPr sz="2700" b="1">
                 <a:solidFill>
                   <a:srgbClr val="15866C"/>
@@ -8276,7 +8299,7 @@
                 <a:cs typeface="Arial"/>
               </a:defRPr>
             </a:lvl5pPr>
-            <a:lvl6pPr algn="l">
+            <a:lvl6pPr>
               <a:defRPr sz="2700" b="1">
                 <a:solidFill>
                   <a:srgbClr val="15866C"/>
@@ -8286,7 +8309,7 @@
                 <a:cs typeface="Arial"/>
               </a:defRPr>
             </a:lvl6pPr>
-            <a:lvl7pPr algn="l">
+            <a:lvl7pPr>
               <a:defRPr sz="2700" b="1">
                 <a:solidFill>
                   <a:srgbClr val="15866C"/>
@@ -8296,7 +8319,7 @@
                 <a:cs typeface="Arial"/>
               </a:defRPr>
             </a:lvl7pPr>
-            <a:lvl8pPr algn="l">
+            <a:lvl8pPr>
               <a:defRPr sz="2700" b="1">
                 <a:solidFill>
                   <a:srgbClr val="15866C"/>
@@ -8306,7 +8329,7 @@
                 <a:cs typeface="Arial"/>
               </a:defRPr>
             </a:lvl8pPr>
-            <a:lvl9pPr algn="l">
+            <a:lvl9pPr>
               <a:defRPr sz="2700" b="1">
                 <a:solidFill>
                   <a:srgbClr val="15866C"/>
@@ -8318,7 +8341,7 @@
             </a:lvl9pPr>
           </a:lstStyle>
           <a:p xmlns:a="http://schemas.openxmlformats.org/drawingml/2006/main">
-            <a:pPr algn="l">
+            <a:pPr>
               <a:defRPr sz="2700" b="1">
                 <a:solidFill>
                   <a:srgbClr val="15866C"/>
@@ -8344,10 +8367,10 @@
       </p:sp>
       <p:sp>
         <p:nvSpPr>
-          <p:cNvPr id="13" name="Upload a CSV of profile data">
+          <p:cNvPr id="13" name="Upload profiles and rank a shortlist">
             <a:extLst xmlns:a="http://schemas.openxmlformats.org/drawingml/2006/main">
               <a:ext uri="{FF2B5EF4-FFF2-40B4-BE49-F238E27FC236}">
-                <a16:creationId xmlns:a16="http://schemas.microsoft.com/office/drawing/2014/main" id="{0F211747-F33C-4420-AF1C-D66764086C9A}"/>
+                <a16:creationId xmlns:a16="http://schemas.microsoft.com/office/drawing/2014/main" id="{17C91910-11F5-4385-8D59-1530351A113B}"/>
               </a:ext>
             </a:extLst>
           </p:cNvPr>
@@ -8374,7 +8397,7 @@
             <a:noAutofit/>
           </a:bodyPr>
           <a:lstStyle xmlns:a="http://schemas.openxmlformats.org/drawingml/2006/main">
-            <a:defPPr algn="l">
+            <a:defPPr>
               <a:defRPr sz="2175" b="0">
                 <a:solidFill>
                   <a:srgbClr val="102C32"/>
@@ -8384,7 +8407,7 @@
                 <a:cs typeface="Arial"/>
               </a:defRPr>
             </a:defPPr>
-            <a:lvl1pPr algn="l">
+            <a:lvl1pPr>
               <a:defRPr sz="2175" b="0">
                 <a:solidFill>
                   <a:srgbClr val="102C32"/>
@@ -8394,7 +8417,7 @@
                 <a:cs typeface="Arial"/>
               </a:defRPr>
             </a:lvl1pPr>
-            <a:lvl2pPr algn="l">
+            <a:lvl2pPr>
               <a:defRPr sz="2175" b="0">
                 <a:solidFill>
                   <a:srgbClr val="102C32"/>
@@ -8404,7 +8427,7 @@
                 <a:cs typeface="Arial"/>
               </a:defRPr>
             </a:lvl2pPr>
-            <a:lvl3pPr algn="l">
+            <a:lvl3pPr>
               <a:defRPr sz="2175" b="0">
                 <a:solidFill>
                   <a:srgbClr val="102C32"/>
@@ -8414,7 +8437,7 @@
                 <a:cs typeface="Arial"/>
               </a:defRPr>
             </a:lvl3pPr>
-            <a:lvl4pPr algn="l">
+            <a:lvl4pPr>
               <a:defRPr sz="2175" b="0">
                 <a:solidFill>
                   <a:srgbClr val="102C32"/>
@@ -8424,7 +8447,7 @@
                 <a:cs typeface="Arial"/>
               </a:defRPr>
             </a:lvl4pPr>
-            <a:lvl5pPr algn="l">
+            <a:lvl5pPr>
               <a:defRPr sz="2175" b="0">
                 <a:solidFill>
                   <a:srgbClr val="102C32"/>
@@ -8434,7 +8457,7 @@
                 <a:cs typeface="Arial"/>
               </a:defRPr>
             </a:lvl5pPr>
-            <a:lvl6pPr algn="l">
+            <a:lvl6pPr>
               <a:defRPr sz="2175" b="0">
                 <a:solidFill>
                   <a:srgbClr val="102C32"/>
@@ -8444,7 +8467,7 @@
                 <a:cs typeface="Arial"/>
               </a:defRPr>
             </a:lvl6pPr>
-            <a:lvl7pPr algn="l">
+            <a:lvl7pPr>
               <a:defRPr sz="2175" b="0">
                 <a:solidFill>
                   <a:srgbClr val="102C32"/>
@@ -8454,7 +8477,7 @@
                 <a:cs typeface="Arial"/>
               </a:defRPr>
             </a:lvl7pPr>
-            <a:lvl8pPr algn="l">
+            <a:lvl8pPr>
               <a:defRPr sz="2175" b="0">
                 <a:solidFill>
                   <a:srgbClr val="102C32"/>
@@ -8464,7 +8487,7 @@
                 <a:cs typeface="Arial"/>
               </a:defRPr>
             </a:lvl8pPr>
-            <a:lvl9pPr algn="l">
+            <a:lvl9pPr>
               <a:defRPr sz="2175" b="0">
                 <a:solidFill>
                   <a:srgbClr val="102C32"/>
@@ -8476,7 +8499,7 @@
             </a:lvl9pPr>
           </a:lstStyle>
           <a:p xmlns:a="http://schemas.openxmlformats.org/drawingml/2006/main">
-            <a:pPr algn="l">
+            <a:pPr>
               <a:defRPr sz="2175" b="0">
                 <a:solidFill>
                   <a:srgbClr val="102C32"/>
@@ -8495,7 +8518,7 @@
                 <a:ea typeface="Arial"/>
                 <a:cs typeface="Arial"/>
               </a:rPr>
-              <a:t>Upload a CSV of profile data</a:t>
+              <a:t>Upload profiles and rank a shortlist</a:t>
             </a:r>
           </a:p>
         </p:txBody>
@@ -8505,7 +8528,7 @@
           <p:cNvPr id="14" name="2">
             <a:extLst xmlns:a="http://schemas.openxmlformats.org/drawingml/2006/main">
               <a:ext uri="{FF2B5EF4-FFF2-40B4-BE49-F238E27FC236}">
-                <a16:creationId xmlns:a16="http://schemas.microsoft.com/office/drawing/2014/main" id="{EC6B8421-7E4A-4178-8DDB-32F9910429FC}"/>
+                <a16:creationId xmlns:a16="http://schemas.microsoft.com/office/drawing/2014/main" id="{F40CA098-A7C0-469B-A089-9AA03669221C}"/>
               </a:ext>
             </a:extLst>
           </p:cNvPr>
@@ -8532,7 +8555,7 @@
             <a:noAutofit/>
           </a:bodyPr>
           <a:lstStyle xmlns:a="http://schemas.openxmlformats.org/drawingml/2006/main">
-            <a:defPPr algn="l">
+            <a:defPPr>
               <a:defRPr sz="2700" b="1">
                 <a:solidFill>
                   <a:srgbClr val="15866C"/>
@@ -8542,7 +8565,7 @@
                 <a:cs typeface="Arial"/>
               </a:defRPr>
             </a:defPPr>
-            <a:lvl1pPr algn="l">
+            <a:lvl1pPr>
               <a:defRPr sz="2700" b="1">
                 <a:solidFill>
                   <a:srgbClr val="15866C"/>
@@ -8552,7 +8575,7 @@
                 <a:cs typeface="Arial"/>
               </a:defRPr>
             </a:lvl1pPr>
-            <a:lvl2pPr algn="l">
+            <a:lvl2pPr>
               <a:defRPr sz="2700" b="1">
                 <a:solidFill>
                   <a:srgbClr val="15866C"/>
@@ -8562,7 +8585,7 @@
                 <a:cs typeface="Arial"/>
               </a:defRPr>
             </a:lvl2pPr>
-            <a:lvl3pPr algn="l">
+            <a:lvl3pPr>
               <a:defRPr sz="2700" b="1">
                 <a:solidFill>
                   <a:srgbClr val="15866C"/>
@@ -8572,7 +8595,7 @@
                 <a:cs typeface="Arial"/>
               </a:defRPr>
             </a:lvl3pPr>
-            <a:lvl4pPr algn="l">
+            <a:lvl4pPr>
               <a:defRPr sz="2700" b="1">
                 <a:solidFill>
                   <a:srgbClr val="15866C"/>
@@ -8582,7 +8605,7 @@
                 <a:cs typeface="Arial"/>
               </a:defRPr>
             </a:lvl4pPr>
-            <a:lvl5pPr algn="l">
+            <a:lvl5pPr>
               <a:defRPr sz="2700" b="1">
                 <a:solidFill>
                   <a:srgbClr val="15866C"/>
@@ -8592,7 +8615,7 @@
                 <a:cs typeface="Arial"/>
               </a:defRPr>
             </a:lvl5pPr>
-            <a:lvl6pPr algn="l">
+            <a:lvl6pPr>
               <a:defRPr sz="2700" b="1">
                 <a:solidFill>
                   <a:srgbClr val="15866C"/>
@@ -8602,7 +8625,7 @@
                 <a:cs typeface="Arial"/>
               </a:defRPr>
             </a:lvl6pPr>
-            <a:lvl7pPr algn="l">
+            <a:lvl7pPr>
               <a:defRPr sz="2700" b="1">
                 <a:solidFill>
                   <a:srgbClr val="15866C"/>
@@ -8612,7 +8635,7 @@
                 <a:cs typeface="Arial"/>
               </a:defRPr>
             </a:lvl7pPr>
-            <a:lvl8pPr algn="l">
+            <a:lvl8pPr>
               <a:defRPr sz="2700" b="1">
                 <a:solidFill>
                   <a:srgbClr val="15866C"/>
@@ -8622,7 +8645,7 @@
                 <a:cs typeface="Arial"/>
               </a:defRPr>
             </a:lvl8pPr>
-            <a:lvl9pPr algn="l">
+            <a:lvl9pPr>
               <a:defRPr sz="2700" b="1">
                 <a:solidFill>
                   <a:srgbClr val="15866C"/>
@@ -8634,7 +8657,7 @@
             </a:lvl9pPr>
           </a:lstStyle>
           <a:p xmlns:a="http://schemas.openxmlformats.org/drawingml/2006/main">
-            <a:pPr algn="l">
+            <a:pPr>
               <a:defRPr sz="2700" b="1">
                 <a:solidFill>
                   <a:srgbClr val="15866C"/>
@@ -8660,10 +8683,10 @@
       </p:sp>
       <p:sp>
         <p:nvSpPr>
-          <p:cNvPr id="15" name="Choose how many profiles to review">
+          <p:cNvPr id="15" name="Select a customer and review the facts">
             <a:extLst xmlns:a="http://schemas.openxmlformats.org/drawingml/2006/main">
               <a:ext uri="{FF2B5EF4-FFF2-40B4-BE49-F238E27FC236}">
-                <a16:creationId xmlns:a16="http://schemas.microsoft.com/office/drawing/2014/main" id="{3562FABB-C124-4EE2-B72E-B131FA7DE052}"/>
+                <a16:creationId xmlns:a16="http://schemas.microsoft.com/office/drawing/2014/main" id="{7D96D191-A803-465D-BA18-D0E72B5D1C5E}"/>
               </a:ext>
             </a:extLst>
           </p:cNvPr>
@@ -8690,7 +8713,7 @@
             <a:noAutofit/>
           </a:bodyPr>
           <a:lstStyle xmlns:a="http://schemas.openxmlformats.org/drawingml/2006/main">
-            <a:defPPr algn="l">
+            <a:defPPr>
               <a:defRPr sz="2175" b="0">
                 <a:solidFill>
                   <a:srgbClr val="102C32"/>
@@ -8700,7 +8723,7 @@
                 <a:cs typeface="Arial"/>
               </a:defRPr>
             </a:defPPr>
-            <a:lvl1pPr algn="l">
+            <a:lvl1pPr>
               <a:defRPr sz="2175" b="0">
                 <a:solidFill>
                   <a:srgbClr val="102C32"/>
@@ -8710,7 +8733,7 @@
                 <a:cs typeface="Arial"/>
               </a:defRPr>
             </a:lvl1pPr>
-            <a:lvl2pPr algn="l">
+            <a:lvl2pPr>
               <a:defRPr sz="2175" b="0">
                 <a:solidFill>
                   <a:srgbClr val="102C32"/>
@@ -8720,7 +8743,7 @@
                 <a:cs typeface="Arial"/>
               </a:defRPr>
             </a:lvl2pPr>
-            <a:lvl3pPr algn="l">
+            <a:lvl3pPr>
               <a:defRPr sz="2175" b="0">
                 <a:solidFill>
                   <a:srgbClr val="102C32"/>
@@ -8730,7 +8753,7 @@
                 <a:cs typeface="Arial"/>
               </a:defRPr>
             </a:lvl3pPr>
-            <a:lvl4pPr algn="l">
+            <a:lvl4pPr>
               <a:defRPr sz="2175" b="0">
                 <a:solidFill>
                   <a:srgbClr val="102C32"/>
@@ -8740,7 +8763,7 @@
                 <a:cs typeface="Arial"/>
               </a:defRPr>
             </a:lvl4pPr>
-            <a:lvl5pPr algn="l">
+            <a:lvl5pPr>
               <a:defRPr sz="2175" b="0">
                 <a:solidFill>
                   <a:srgbClr val="102C32"/>
@@ -8750,7 +8773,7 @@
                 <a:cs typeface="Arial"/>
               </a:defRPr>
             </a:lvl5pPr>
-            <a:lvl6pPr algn="l">
+            <a:lvl6pPr>
               <a:defRPr sz="2175" b="0">
                 <a:solidFill>
                   <a:srgbClr val="102C32"/>
@@ -8760,7 +8783,7 @@
                 <a:cs typeface="Arial"/>
               </a:defRPr>
             </a:lvl6pPr>
-            <a:lvl7pPr algn="l">
+            <a:lvl7pPr>
               <a:defRPr sz="2175" b="0">
                 <a:solidFill>
                   <a:srgbClr val="102C32"/>
@@ -8770,7 +8793,7 @@
                 <a:cs typeface="Arial"/>
               </a:defRPr>
             </a:lvl7pPr>
-            <a:lvl8pPr algn="l">
+            <a:lvl8pPr>
               <a:defRPr sz="2175" b="0">
                 <a:solidFill>
                   <a:srgbClr val="102C32"/>
@@ -8780,7 +8803,7 @@
                 <a:cs typeface="Arial"/>
               </a:defRPr>
             </a:lvl8pPr>
-            <a:lvl9pPr algn="l">
+            <a:lvl9pPr>
               <a:defRPr sz="2175" b="0">
                 <a:solidFill>
                   <a:srgbClr val="102C32"/>
@@ -8792,7 +8815,7 @@
             </a:lvl9pPr>
           </a:lstStyle>
           <a:p xmlns:a="http://schemas.openxmlformats.org/drawingml/2006/main">
-            <a:pPr algn="l">
+            <a:pPr>
               <a:defRPr sz="2175" b="0">
                 <a:solidFill>
                   <a:srgbClr val="102C32"/>
@@ -8811,7 +8834,7 @@
                 <a:ea typeface="Arial"/>
                 <a:cs typeface="Arial"/>
               </a:rPr>
-              <a:t>Choose how many profiles to review</a:t>
+              <a:t>Select a customer and review the facts</a:t>
             </a:r>
           </a:p>
         </p:txBody>
@@ -8821,7 +8844,7 @@
           <p:cNvPr id="16" name="3">
             <a:extLst xmlns:a="http://schemas.openxmlformats.org/drawingml/2006/main">
               <a:ext uri="{FF2B5EF4-FFF2-40B4-BE49-F238E27FC236}">
-                <a16:creationId xmlns:a16="http://schemas.microsoft.com/office/drawing/2014/main" id="{145DA41E-8F83-4BFD-965D-958E3A65E899}"/>
+                <a16:creationId xmlns:a16="http://schemas.microsoft.com/office/drawing/2014/main" id="{6F1BE8CB-B231-4760-9309-F6900EDE7E2B}"/>
               </a:ext>
             </a:extLst>
           </p:cNvPr>
@@ -8848,7 +8871,7 @@
             <a:noAutofit/>
           </a:bodyPr>
           <a:lstStyle xmlns:a="http://schemas.openxmlformats.org/drawingml/2006/main">
-            <a:defPPr algn="l">
+            <a:defPPr>
               <a:defRPr sz="2700" b="1">
                 <a:solidFill>
                   <a:srgbClr val="15866C"/>
@@ -8858,7 +8881,7 @@
                 <a:cs typeface="Arial"/>
               </a:defRPr>
             </a:defPPr>
-            <a:lvl1pPr algn="l">
+            <a:lvl1pPr>
               <a:defRPr sz="2700" b="1">
                 <a:solidFill>
                   <a:srgbClr val="15866C"/>
@@ -8868,7 +8891,7 @@
                 <a:cs typeface="Arial"/>
               </a:defRPr>
             </a:lvl1pPr>
-            <a:lvl2pPr algn="l">
+            <a:lvl2pPr>
               <a:defRPr sz="2700" b="1">
                 <a:solidFill>
                   <a:srgbClr val="15866C"/>
@@ -8878,7 +8901,7 @@
                 <a:cs typeface="Arial"/>
               </a:defRPr>
             </a:lvl2pPr>
-            <a:lvl3pPr algn="l">
+            <a:lvl3pPr>
               <a:defRPr sz="2700" b="1">
                 <a:solidFill>
                   <a:srgbClr val="15866C"/>
@@ -8888,7 +8911,7 @@
                 <a:cs typeface="Arial"/>
               </a:defRPr>
             </a:lvl3pPr>
-            <a:lvl4pPr algn="l">
+            <a:lvl4pPr>
               <a:defRPr sz="2700" b="1">
                 <a:solidFill>
                   <a:srgbClr val="15866C"/>
@@ -8898,7 +8921,7 @@
                 <a:cs typeface="Arial"/>
               </a:defRPr>
             </a:lvl4pPr>
-            <a:lvl5pPr algn="l">
+            <a:lvl5pPr>
               <a:defRPr sz="2700" b="1">
                 <a:solidFill>
                   <a:srgbClr val="15866C"/>
@@ -8908,7 +8931,7 @@
                 <a:cs typeface="Arial"/>
               </a:defRPr>
             </a:lvl5pPr>
-            <a:lvl6pPr algn="l">
+            <a:lvl6pPr>
               <a:defRPr sz="2700" b="1">
                 <a:solidFill>
                   <a:srgbClr val="15866C"/>
@@ -8918,7 +8941,7 @@
                 <a:cs typeface="Arial"/>
               </a:defRPr>
             </a:lvl6pPr>
-            <a:lvl7pPr algn="l">
+            <a:lvl7pPr>
               <a:defRPr sz="2700" b="1">
                 <a:solidFill>
                   <a:srgbClr val="15866C"/>
@@ -8928,7 +8951,7 @@
                 <a:cs typeface="Arial"/>
               </a:defRPr>
             </a:lvl7pPr>
-            <a:lvl8pPr algn="l">
+            <a:lvl8pPr>
               <a:defRPr sz="2700" b="1">
                 <a:solidFill>
                   <a:srgbClr val="15866C"/>
@@ -8938,7 +8961,7 @@
                 <a:cs typeface="Arial"/>
               </a:defRPr>
             </a:lvl8pPr>
-            <a:lvl9pPr algn="l">
+            <a:lvl9pPr>
               <a:defRPr sz="2700" b="1">
                 <a:solidFill>
                   <a:srgbClr val="15866C"/>
@@ -8950,7 +8973,7 @@
             </a:lvl9pPr>
           </a:lstStyle>
           <a:p xmlns:a="http://schemas.openxmlformats.org/drawingml/2006/main">
-            <a:pPr algn="l">
+            <a:pPr>
               <a:defRPr sz="2700" b="1">
                 <a:solidFill>
                   <a:srgbClr val="15866C"/>
@@ -8976,10 +8999,10 @@
       </p:sp>
       <p:sp>
         <p:nvSpPr>
-          <p:cNvPr id="17" name="Review ranked IDs and recorded fields">
+          <p:cNvPr id="17" name="Edit the customer’s conversation guide">
             <a:extLst xmlns:a="http://schemas.openxmlformats.org/drawingml/2006/main">
               <a:ext uri="{FF2B5EF4-FFF2-40B4-BE49-F238E27FC236}">
-                <a16:creationId xmlns:a16="http://schemas.microsoft.com/office/drawing/2014/main" id="{EBED9659-B74D-4DC9-95A4-05EDA0186C64}"/>
+                <a16:creationId xmlns:a16="http://schemas.microsoft.com/office/drawing/2014/main" id="{C3582BA1-EA11-411C-A33D-44EBD4BD001F}"/>
               </a:ext>
             </a:extLst>
           </p:cNvPr>
@@ -9006,7 +9029,7 @@
             <a:noAutofit/>
           </a:bodyPr>
           <a:lstStyle xmlns:a="http://schemas.openxmlformats.org/drawingml/2006/main">
-            <a:defPPr algn="l">
+            <a:defPPr>
               <a:defRPr sz="2175" b="0">
                 <a:solidFill>
                   <a:srgbClr val="102C32"/>
@@ -9016,7 +9039,7 @@
                 <a:cs typeface="Arial"/>
               </a:defRPr>
             </a:defPPr>
-            <a:lvl1pPr algn="l">
+            <a:lvl1pPr>
               <a:defRPr sz="2175" b="0">
                 <a:solidFill>
                   <a:srgbClr val="102C32"/>
@@ -9026,7 +9049,7 @@
                 <a:cs typeface="Arial"/>
               </a:defRPr>
             </a:lvl1pPr>
-            <a:lvl2pPr algn="l">
+            <a:lvl2pPr>
               <a:defRPr sz="2175" b="0">
                 <a:solidFill>
                   <a:srgbClr val="102C32"/>
@@ -9036,7 +9059,7 @@
                 <a:cs typeface="Arial"/>
               </a:defRPr>
             </a:lvl2pPr>
-            <a:lvl3pPr algn="l">
+            <a:lvl3pPr>
               <a:defRPr sz="2175" b="0">
                 <a:solidFill>
                   <a:srgbClr val="102C32"/>
@@ -9046,7 +9069,7 @@
                 <a:cs typeface="Arial"/>
               </a:defRPr>
             </a:lvl3pPr>
-            <a:lvl4pPr algn="l">
+            <a:lvl4pPr>
               <a:defRPr sz="2175" b="0">
                 <a:solidFill>
                   <a:srgbClr val="102C32"/>
@@ -9056,7 +9079,7 @@
                 <a:cs typeface="Arial"/>
               </a:defRPr>
             </a:lvl4pPr>
-            <a:lvl5pPr algn="l">
+            <a:lvl5pPr>
               <a:defRPr sz="2175" b="0">
                 <a:solidFill>
                   <a:srgbClr val="102C32"/>
@@ -9066,7 +9089,7 @@
                 <a:cs typeface="Arial"/>
               </a:defRPr>
             </a:lvl5pPr>
-            <a:lvl6pPr algn="l">
+            <a:lvl6pPr>
               <a:defRPr sz="2175" b="0">
                 <a:solidFill>
                   <a:srgbClr val="102C32"/>
@@ -9076,7 +9099,7 @@
                 <a:cs typeface="Arial"/>
               </a:defRPr>
             </a:lvl6pPr>
-            <a:lvl7pPr algn="l">
+            <a:lvl7pPr>
               <a:defRPr sz="2175" b="0">
                 <a:solidFill>
                   <a:srgbClr val="102C32"/>
@@ -9086,7 +9109,7 @@
                 <a:cs typeface="Arial"/>
               </a:defRPr>
             </a:lvl7pPr>
-            <a:lvl8pPr algn="l">
+            <a:lvl8pPr>
               <a:defRPr sz="2175" b="0">
                 <a:solidFill>
                   <a:srgbClr val="102C32"/>
@@ -9096,7 +9119,7 @@
                 <a:cs typeface="Arial"/>
               </a:defRPr>
             </a:lvl8pPr>
-            <a:lvl9pPr algn="l">
+            <a:lvl9pPr>
               <a:defRPr sz="2175" b="0">
                 <a:solidFill>
                   <a:srgbClr val="102C32"/>
@@ -9108,7 +9131,7 @@
             </a:lvl9pPr>
           </a:lstStyle>
           <a:p xmlns:a="http://schemas.openxmlformats.org/drawingml/2006/main">
-            <a:pPr algn="l">
+            <a:pPr>
               <a:defRPr sz="2175" b="0">
                 <a:solidFill>
                   <a:srgbClr val="102C32"/>
@@ -9127,7 +9150,7 @@
                 <a:ea typeface="Arial"/>
                 <a:cs typeface="Arial"/>
               </a:rPr>
-              <a:t>Review ranked IDs and recorded fields</a:t>
+              <a:t>Edit the customer’s conversation guide</a:t>
             </a:r>
           </a:p>
         </p:txBody>
@@ -9137,7 +9160,7 @@
           <p:cNvPr id="18" name="4">
             <a:extLst xmlns:a="http://schemas.openxmlformats.org/drawingml/2006/main">
               <a:ext uri="{FF2B5EF4-FFF2-40B4-BE49-F238E27FC236}">
-                <a16:creationId xmlns:a16="http://schemas.microsoft.com/office/drawing/2014/main" id="{8E9149ED-DD9A-478D-870E-8C8C59184395}"/>
+                <a16:creationId xmlns:a16="http://schemas.microsoft.com/office/drawing/2014/main" id="{16DB777A-DA8C-479B-9B2E-D71748CADE37}"/>
               </a:ext>
             </a:extLst>
           </p:cNvPr>
@@ -9164,7 +9187,7 @@
             <a:noAutofit/>
           </a:bodyPr>
           <a:lstStyle xmlns:a="http://schemas.openxmlformats.org/drawingml/2006/main">
-            <a:defPPr algn="l">
+            <a:defPPr>
               <a:defRPr sz="2700" b="1">
                 <a:solidFill>
                   <a:srgbClr val="15866C"/>
@@ -9174,7 +9197,7 @@
                 <a:cs typeface="Arial"/>
               </a:defRPr>
             </a:defPPr>
-            <a:lvl1pPr algn="l">
+            <a:lvl1pPr>
               <a:defRPr sz="2700" b="1">
                 <a:solidFill>
                   <a:srgbClr val="15866C"/>
@@ -9184,7 +9207,7 @@
                 <a:cs typeface="Arial"/>
               </a:defRPr>
             </a:lvl1pPr>
-            <a:lvl2pPr algn="l">
+            <a:lvl2pPr>
               <a:defRPr sz="2700" b="1">
                 <a:solidFill>
                   <a:srgbClr val="15866C"/>
@@ -9194,7 +9217,7 @@
                 <a:cs typeface="Arial"/>
               </a:defRPr>
             </a:lvl2pPr>
-            <a:lvl3pPr algn="l">
+            <a:lvl3pPr>
               <a:defRPr sz="2700" b="1">
                 <a:solidFill>
                   <a:srgbClr val="15866C"/>
@@ -9204,7 +9227,7 @@
                 <a:cs typeface="Arial"/>
               </a:defRPr>
             </a:lvl3pPr>
-            <a:lvl4pPr algn="l">
+            <a:lvl4pPr>
               <a:defRPr sz="2700" b="1">
                 <a:solidFill>
                   <a:srgbClr val="15866C"/>
@@ -9214,7 +9237,7 @@
                 <a:cs typeface="Arial"/>
               </a:defRPr>
             </a:lvl4pPr>
-            <a:lvl5pPr algn="l">
+            <a:lvl5pPr>
               <a:defRPr sz="2700" b="1">
                 <a:solidFill>
                   <a:srgbClr val="15866C"/>
@@ -9224,7 +9247,7 @@
                 <a:cs typeface="Arial"/>
               </a:defRPr>
             </a:lvl5pPr>
-            <a:lvl6pPr algn="l">
+            <a:lvl6pPr>
               <a:defRPr sz="2700" b="1">
                 <a:solidFill>
                   <a:srgbClr val="15866C"/>
@@ -9234,7 +9257,7 @@
                 <a:cs typeface="Arial"/>
               </a:defRPr>
             </a:lvl6pPr>
-            <a:lvl7pPr algn="l">
+            <a:lvl7pPr>
               <a:defRPr sz="2700" b="1">
                 <a:solidFill>
                   <a:srgbClr val="15866C"/>
@@ -9244,7 +9267,7 @@
                 <a:cs typeface="Arial"/>
               </a:defRPr>
             </a:lvl7pPr>
-            <a:lvl8pPr algn="l">
+            <a:lvl8pPr>
               <a:defRPr sz="2700" b="1">
                 <a:solidFill>
                   <a:srgbClr val="15866C"/>
@@ -9254,7 +9277,7 @@
                 <a:cs typeface="Arial"/>
               </a:defRPr>
             </a:lvl8pPr>
-            <a:lvl9pPr algn="l">
+            <a:lvl9pPr>
               <a:defRPr sz="2700" b="1">
                 <a:solidFill>
                   <a:srgbClr val="15866C"/>
@@ -9266,7 +9289,7 @@
             </a:lvl9pPr>
           </a:lstStyle>
           <a:p xmlns:a="http://schemas.openxmlformats.org/drawingml/2006/main">
-            <a:pPr algn="l">
+            <a:pPr>
               <a:defRPr sz="2700" b="1">
                 <a:solidFill>
                   <a:srgbClr val="15866C"/>
@@ -9292,10 +9315,10 @@
       </p:sp>
       <p:sp>
         <p:nvSpPr>
-          <p:cNvPr id="19" name="Download the shortlist as a CSV">
+          <p:cNvPr id="19" name="Download a script or guides for the list">
             <a:extLst xmlns:a="http://schemas.openxmlformats.org/drawingml/2006/main">
               <a:ext uri="{FF2B5EF4-FFF2-40B4-BE49-F238E27FC236}">
-                <a16:creationId xmlns:a16="http://schemas.microsoft.com/office/drawing/2014/main" id="{8F2F5263-3957-482C-B19A-AB8AB1CBBB0D}"/>
+                <a16:creationId xmlns:a16="http://schemas.microsoft.com/office/drawing/2014/main" id="{0F3C41E6-B168-4829-94C6-A33FA77783EB}"/>
               </a:ext>
             </a:extLst>
           </p:cNvPr>
@@ -9322,7 +9345,7 @@
             <a:noAutofit/>
           </a:bodyPr>
           <a:lstStyle xmlns:a="http://schemas.openxmlformats.org/drawingml/2006/main">
-            <a:defPPr algn="l">
+            <a:defPPr>
               <a:defRPr sz="2175" b="0">
                 <a:solidFill>
                   <a:srgbClr val="102C32"/>
@@ -9332,7 +9355,7 @@
                 <a:cs typeface="Arial"/>
               </a:defRPr>
             </a:defPPr>
-            <a:lvl1pPr algn="l">
+            <a:lvl1pPr>
               <a:defRPr sz="2175" b="0">
                 <a:solidFill>
                   <a:srgbClr val="102C32"/>
@@ -9342,7 +9365,7 @@
                 <a:cs typeface="Arial"/>
               </a:defRPr>
             </a:lvl1pPr>
-            <a:lvl2pPr algn="l">
+            <a:lvl2pPr>
               <a:defRPr sz="2175" b="0">
                 <a:solidFill>
                   <a:srgbClr val="102C32"/>
@@ -9352,7 +9375,7 @@
                 <a:cs typeface="Arial"/>
               </a:defRPr>
             </a:lvl2pPr>
-            <a:lvl3pPr algn="l">
+            <a:lvl3pPr>
               <a:defRPr sz="2175" b="0">
                 <a:solidFill>
                   <a:srgbClr val="102C32"/>
@@ -9362,7 +9385,7 @@
                 <a:cs typeface="Arial"/>
               </a:defRPr>
             </a:lvl3pPr>
-            <a:lvl4pPr algn="l">
+            <a:lvl4pPr>
               <a:defRPr sz="2175" b="0">
                 <a:solidFill>
                   <a:srgbClr val="102C32"/>
@@ -9372,7 +9395,7 @@
                 <a:cs typeface="Arial"/>
               </a:defRPr>
             </a:lvl4pPr>
-            <a:lvl5pPr algn="l">
+            <a:lvl5pPr>
               <a:defRPr sz="2175" b="0">
                 <a:solidFill>
                   <a:srgbClr val="102C32"/>
@@ -9382,7 +9405,7 @@
                 <a:cs typeface="Arial"/>
               </a:defRPr>
             </a:lvl5pPr>
-            <a:lvl6pPr algn="l">
+            <a:lvl6pPr>
               <a:defRPr sz="2175" b="0">
                 <a:solidFill>
                   <a:srgbClr val="102C32"/>
@@ -9392,7 +9415,7 @@
                 <a:cs typeface="Arial"/>
               </a:defRPr>
             </a:lvl6pPr>
-            <a:lvl7pPr algn="l">
+            <a:lvl7pPr>
               <a:defRPr sz="2175" b="0">
                 <a:solidFill>
                   <a:srgbClr val="102C32"/>
@@ -9402,7 +9425,7 @@
                 <a:cs typeface="Arial"/>
               </a:defRPr>
             </a:lvl7pPr>
-            <a:lvl8pPr algn="l">
+            <a:lvl8pPr>
               <a:defRPr sz="2175" b="0">
                 <a:solidFill>
                   <a:srgbClr val="102C32"/>
@@ -9412,7 +9435,7 @@
                 <a:cs typeface="Arial"/>
               </a:defRPr>
             </a:lvl8pPr>
-            <a:lvl9pPr algn="l">
+            <a:lvl9pPr>
               <a:defRPr sz="2175" b="0">
                 <a:solidFill>
                   <a:srgbClr val="102C32"/>
@@ -9424,7 +9447,7 @@
             </a:lvl9pPr>
           </a:lstStyle>
           <a:p xmlns:a="http://schemas.openxmlformats.org/drawingml/2006/main">
-            <a:pPr algn="l">
+            <a:pPr>
               <a:defRPr sz="2175" b="0">
                 <a:solidFill>
                   <a:srgbClr val="102C32"/>
@@ -9443,17 +9466,17 @@
                 <a:ea typeface="Arial"/>
                 <a:cs typeface="Arial"/>
               </a:rPr>
-              <a:t>Download the shortlist as a CSV</a:t>
+              <a:t>Download a script or guides for the list</a:t>
             </a:r>
           </a:p>
         </p:txBody>
       </p:sp>
       <p:sp>
         <p:nvSpPr>
-          <p:cNvPr id="20" name="Input checks">
+          <p:cNvPr id="20" name="Five guide sections">
             <a:extLst xmlns:a="http://schemas.openxmlformats.org/drawingml/2006/main">
               <a:ext uri="{FF2B5EF4-FFF2-40B4-BE49-F238E27FC236}">
-                <a16:creationId xmlns:a16="http://schemas.microsoft.com/office/drawing/2014/main" id="{5D5D3318-AA27-426E-A388-CA8AECB5054B}"/>
+                <a16:creationId xmlns:a16="http://schemas.microsoft.com/office/drawing/2014/main" id="{CF1429B8-80D1-4FAB-9196-76809B057EB1}"/>
               </a:ext>
             </a:extLst>
           </p:cNvPr>
@@ -9480,8 +9503,8 @@
             <a:noAutofit/>
           </a:bodyPr>
           <a:lstStyle xmlns:a="http://schemas.openxmlformats.org/drawingml/2006/main">
-            <a:defPPr algn="l">
-              <a:defRPr sz="2175" b="1">
+            <a:defPPr>
+              <a:defRPr sz="2025" b="1">
                 <a:solidFill>
                   <a:srgbClr val="102C32"/>
                 </a:solidFill>
@@ -9490,8 +9513,8 @@
                 <a:cs typeface="Arial"/>
               </a:defRPr>
             </a:defPPr>
-            <a:lvl1pPr algn="l">
-              <a:defRPr sz="2175" b="1">
+            <a:lvl1pPr>
+              <a:defRPr sz="2025" b="1">
                 <a:solidFill>
                   <a:srgbClr val="102C32"/>
                 </a:solidFill>
@@ -9500,8 +9523,8 @@
                 <a:cs typeface="Arial"/>
               </a:defRPr>
             </a:lvl1pPr>
-            <a:lvl2pPr algn="l">
-              <a:defRPr sz="2175" b="1">
+            <a:lvl2pPr>
+              <a:defRPr sz="2025" b="1">
                 <a:solidFill>
                   <a:srgbClr val="102C32"/>
                 </a:solidFill>
@@ -9510,8 +9533,8 @@
                 <a:cs typeface="Arial"/>
               </a:defRPr>
             </a:lvl2pPr>
-            <a:lvl3pPr algn="l">
-              <a:defRPr sz="2175" b="1">
+            <a:lvl3pPr>
+              <a:defRPr sz="2025" b="1">
                 <a:solidFill>
                   <a:srgbClr val="102C32"/>
                 </a:solidFill>
@@ -9520,8 +9543,8 @@
                 <a:cs typeface="Arial"/>
               </a:defRPr>
             </a:lvl3pPr>
-            <a:lvl4pPr algn="l">
-              <a:defRPr sz="2175" b="1">
+            <a:lvl4pPr>
+              <a:defRPr sz="2025" b="1">
                 <a:solidFill>
                   <a:srgbClr val="102C32"/>
                 </a:solidFill>
@@ -9530,8 +9553,8 @@
                 <a:cs typeface="Arial"/>
               </a:defRPr>
             </a:lvl4pPr>
-            <a:lvl5pPr algn="l">
-              <a:defRPr sz="2175" b="1">
+            <a:lvl5pPr>
+              <a:defRPr sz="2025" b="1">
                 <a:solidFill>
                   <a:srgbClr val="102C32"/>
                 </a:solidFill>
@@ -9540,8 +9563,8 @@
                 <a:cs typeface="Arial"/>
               </a:defRPr>
             </a:lvl5pPr>
-            <a:lvl6pPr algn="l">
-              <a:defRPr sz="2175" b="1">
+            <a:lvl6pPr>
+              <a:defRPr sz="2025" b="1">
                 <a:solidFill>
                   <a:srgbClr val="102C32"/>
                 </a:solidFill>
@@ -9550,8 +9573,8 @@
                 <a:cs typeface="Arial"/>
               </a:defRPr>
             </a:lvl6pPr>
-            <a:lvl7pPr algn="l">
-              <a:defRPr sz="2175" b="1">
+            <a:lvl7pPr>
+              <a:defRPr sz="2025" b="1">
                 <a:solidFill>
                   <a:srgbClr val="102C32"/>
                 </a:solidFill>
@@ -9560,8 +9583,8 @@
                 <a:cs typeface="Arial"/>
               </a:defRPr>
             </a:lvl7pPr>
-            <a:lvl8pPr algn="l">
-              <a:defRPr sz="2175" b="1">
+            <a:lvl8pPr>
+              <a:defRPr sz="2025" b="1">
                 <a:solidFill>
                   <a:srgbClr val="102C32"/>
                 </a:solidFill>
@@ -9570,8 +9593,8 @@
                 <a:cs typeface="Arial"/>
               </a:defRPr>
             </a:lvl8pPr>
-            <a:lvl9pPr algn="l">
-              <a:defRPr sz="2175" b="1">
+            <a:lvl9pPr>
+              <a:defRPr sz="2025" b="1">
                 <a:solidFill>
                   <a:srgbClr val="102C32"/>
                 </a:solidFill>
@@ -9582,8 +9605,8 @@
             </a:lvl9pPr>
           </a:lstStyle>
           <a:p xmlns:a="http://schemas.openxmlformats.org/drawingml/2006/main">
-            <a:pPr algn="l">
-              <a:defRPr sz="2175" b="1">
+            <a:pPr>
+              <a:defRPr sz="2025" b="1">
                 <a:solidFill>
                   <a:srgbClr val="102C32"/>
                 </a:solidFill>
@@ -9593,7 +9616,7 @@
               </a:defRPr>
             </a:pPr>
             <a:r>
-              <a:rPr sz="2175" b="1">
+              <a:rPr sz="2025" b="1">
                 <a:solidFill>
                   <a:srgbClr val="102C32"/>
                 </a:solidFill>
@@ -9601,17 +9624,17 @@
                 <a:ea typeface="Arial"/>
                 <a:cs typeface="Arial"/>
               </a:rPr>
-              <a:t>Input checks</a:t>
+              <a:t>Five guide sections</a:t>
             </a:r>
           </a:p>
         </p:txBody>
       </p:sp>
       <p:sp>
         <p:nvSpPr>
-          <p:cNvPr id="21" name="Missing fields and&#10;unsupported values&#10;trigger ">
+          <p:cNvPr id="21" name="Opening&#10;Needs questions&#10;Discussion topics&#10;Conc">
             <a:extLst xmlns:a="http://schemas.openxmlformats.org/drawingml/2006/main">
               <a:ext uri="{FF2B5EF4-FFF2-40B4-BE49-F238E27FC236}">
-                <a16:creationId xmlns:a16="http://schemas.microsoft.com/office/drawing/2014/main" id="{2D1314D4-8C31-4EFD-A377-80EC326A38BB}"/>
+                <a16:creationId xmlns:a16="http://schemas.microsoft.com/office/drawing/2014/main" id="{94069F39-21F5-4E07-AD33-06B5DA8F8BE2}"/>
               </a:ext>
             </a:extLst>
           </p:cNvPr>
@@ -9623,7 +9646,7 @@
         <p:spPr>
           <a:xfrm xmlns:a="http://schemas.openxmlformats.org/drawingml/2006/main">
             <a:off x="8667750" y="2867025"/>
-            <a:ext cx="2895600" cy="1104900"/>
+            <a:ext cx="2895600" cy="1924050"/>
           </a:xfrm>
           <a:prstGeom xmlns:a="http://schemas.openxmlformats.org/drawingml/2006/main" prst="rect">
             <a:avLst/>
@@ -9638,8 +9661,8 @@
             <a:noAutofit/>
           </a:bodyPr>
           <a:lstStyle xmlns:a="http://schemas.openxmlformats.org/drawingml/2006/main">
-            <a:defPPr algn="l">
-              <a:defRPr sz="2025" b="0">
+            <a:defPPr>
+              <a:defRPr sz="1875" b="0">
                 <a:solidFill>
                   <a:srgbClr val="102C32"/>
                 </a:solidFill>
@@ -9648,8 +9671,8 @@
                 <a:cs typeface="Arial"/>
               </a:defRPr>
             </a:defPPr>
-            <a:lvl1pPr algn="l">
-              <a:defRPr sz="2025" b="0">
+            <a:lvl1pPr>
+              <a:defRPr sz="1875" b="0">
                 <a:solidFill>
                   <a:srgbClr val="102C32"/>
                 </a:solidFill>
@@ -9658,8 +9681,8 @@
                 <a:cs typeface="Arial"/>
               </a:defRPr>
             </a:lvl1pPr>
-            <a:lvl2pPr algn="l">
-              <a:defRPr sz="2025" b="0">
+            <a:lvl2pPr>
+              <a:defRPr sz="1875" b="0">
                 <a:solidFill>
                   <a:srgbClr val="102C32"/>
                 </a:solidFill>
@@ -9668,8 +9691,8 @@
                 <a:cs typeface="Arial"/>
               </a:defRPr>
             </a:lvl2pPr>
-            <a:lvl3pPr algn="l">
-              <a:defRPr sz="2025" b="0">
+            <a:lvl3pPr>
+              <a:defRPr sz="1875" b="0">
                 <a:solidFill>
                   <a:srgbClr val="102C32"/>
                 </a:solidFill>
@@ -9678,8 +9701,8 @@
                 <a:cs typeface="Arial"/>
               </a:defRPr>
             </a:lvl3pPr>
-            <a:lvl4pPr algn="l">
-              <a:defRPr sz="2025" b="0">
+            <a:lvl4pPr>
+              <a:defRPr sz="1875" b="0">
                 <a:solidFill>
                   <a:srgbClr val="102C32"/>
                 </a:solidFill>
@@ -9688,8 +9711,8 @@
                 <a:cs typeface="Arial"/>
               </a:defRPr>
             </a:lvl4pPr>
-            <a:lvl5pPr algn="l">
-              <a:defRPr sz="2025" b="0">
+            <a:lvl5pPr>
+              <a:defRPr sz="1875" b="0">
                 <a:solidFill>
                   <a:srgbClr val="102C32"/>
                 </a:solidFill>
@@ -9698,8 +9721,8 @@
                 <a:cs typeface="Arial"/>
               </a:defRPr>
             </a:lvl5pPr>
-            <a:lvl6pPr algn="l">
-              <a:defRPr sz="2025" b="0">
+            <a:lvl6pPr>
+              <a:defRPr sz="1875" b="0">
                 <a:solidFill>
                   <a:srgbClr val="102C32"/>
                 </a:solidFill>
@@ -9708,8 +9731,8 @@
                 <a:cs typeface="Arial"/>
               </a:defRPr>
             </a:lvl6pPr>
-            <a:lvl7pPr algn="l">
-              <a:defRPr sz="2025" b="0">
+            <a:lvl7pPr>
+              <a:defRPr sz="1875" b="0">
                 <a:solidFill>
                   <a:srgbClr val="102C32"/>
                 </a:solidFill>
@@ -9718,8 +9741,8 @@
                 <a:cs typeface="Arial"/>
               </a:defRPr>
             </a:lvl7pPr>
-            <a:lvl8pPr algn="l">
-              <a:defRPr sz="2025" b="0">
+            <a:lvl8pPr>
+              <a:defRPr sz="1875" b="0">
                 <a:solidFill>
                   <a:srgbClr val="102C32"/>
                 </a:solidFill>
@@ -9728,8 +9751,8 @@
                 <a:cs typeface="Arial"/>
               </a:defRPr>
             </a:lvl8pPr>
-            <a:lvl9pPr algn="l">
-              <a:defRPr sz="2025" b="0">
+            <a:lvl9pPr>
+              <a:defRPr sz="1875" b="0">
                 <a:solidFill>
                   <a:srgbClr val="102C32"/>
                 </a:solidFill>
@@ -9740,8 +9763,8 @@
             </a:lvl9pPr>
           </a:lstStyle>
           <a:p xmlns:a="http://schemas.openxmlformats.org/drawingml/2006/main">
-            <a:pPr algn="l">
-              <a:defRPr sz="2025" b="0">
+            <a:pPr>
+              <a:defRPr sz="1875" b="0">
                 <a:solidFill>
                   <a:srgbClr val="102C32"/>
                 </a:solidFill>
@@ -9751,7 +9774,7 @@
               </a:defRPr>
             </a:pPr>
             <a:r>
-              <a:rPr sz="2025" b="0">
+              <a:rPr sz="1875" b="0">
                 <a:solidFill>
                   <a:srgbClr val="102C32"/>
                 </a:solidFill>
@@ -9759,12 +9782,12 @@
                 <a:ea typeface="Arial"/>
                 <a:cs typeface="Arial"/>
               </a:rPr>
-              <a:t>Missing fields and</a:t>
-            </a:r>
-          </a:p>
-          <a:p xmlns:a="http://schemas.openxmlformats.org/drawingml/2006/main">
-            <a:pPr algn="l">
-              <a:defRPr sz="2025" b="0">
+              <a:t>Opening</a:t>
+            </a:r>
+          </a:p>
+          <a:p xmlns:a="http://schemas.openxmlformats.org/drawingml/2006/main">
+            <a:pPr>
+              <a:defRPr sz="1875" b="0">
                 <a:solidFill>
                   <a:srgbClr val="102C32"/>
                 </a:solidFill>
@@ -9774,7 +9797,7 @@
               </a:defRPr>
             </a:pPr>
             <a:r>
-              <a:rPr sz="2025" b="0">
+              <a:rPr sz="1875" b="0">
                 <a:solidFill>
                   <a:srgbClr val="102C32"/>
                 </a:solidFill>
@@ -9782,12 +9805,12 @@
                 <a:ea typeface="Arial"/>
                 <a:cs typeface="Arial"/>
               </a:rPr>
-              <a:t>unsupported values</a:t>
-            </a:r>
-          </a:p>
-          <a:p xmlns:a="http://schemas.openxmlformats.org/drawingml/2006/main">
-            <a:pPr algn="l">
-              <a:defRPr sz="2025" b="0">
+              <a:t>Needs questions</a:t>
+            </a:r>
+          </a:p>
+          <a:p xmlns:a="http://schemas.openxmlformats.org/drawingml/2006/main">
+            <a:pPr>
+              <a:defRPr sz="1875" b="0">
                 <a:solidFill>
                   <a:srgbClr val="102C32"/>
                 </a:solidFill>
@@ -9797,7 +9820,7 @@
               </a:defRPr>
             </a:pPr>
             <a:r>
-              <a:rPr sz="2025" b="0">
+              <a:rPr sz="1875" b="0">
                 <a:solidFill>
                   <a:srgbClr val="102C32"/>
                 </a:solidFill>
@@ -9805,17 +9828,86 @@
                 <a:ea typeface="Arial"/>
                 <a:cs typeface="Arial"/>
               </a:rPr>
-              <a:t>trigger a message.</a:t>
+              <a:t>Discussion topics</a:t>
+            </a:r>
+          </a:p>
+          <a:p xmlns:a="http://schemas.openxmlformats.org/drawingml/2006/main">
+            <a:pPr>
+              <a:defRPr sz="1875" b="0">
+                <a:solidFill>
+                  <a:srgbClr val="102C32"/>
+                </a:solidFill>
+                <a:latin typeface="Arial"/>
+                <a:ea typeface="Arial"/>
+                <a:cs typeface="Arial"/>
+              </a:defRPr>
+            </a:pPr>
+            <a:r>
+              <a:rPr sz="1875" b="0">
+                <a:solidFill>
+                  <a:srgbClr val="102C32"/>
+                </a:solidFill>
+                <a:latin typeface="Arial"/>
+                <a:ea typeface="Arial"/>
+                <a:cs typeface="Arial"/>
+              </a:rPr>
+              <a:t>Concerns to explore</a:t>
+            </a:r>
+          </a:p>
+          <a:p xmlns:a="http://schemas.openxmlformats.org/drawingml/2006/main">
+            <a:pPr>
+              <a:defRPr sz="1875" b="0">
+                <a:solidFill>
+                  <a:srgbClr val="102C32"/>
+                </a:solidFill>
+                <a:latin typeface="Arial"/>
+                <a:ea typeface="Arial"/>
+                <a:cs typeface="Arial"/>
+              </a:defRPr>
+            </a:pPr>
+            <a:r>
+              <a:rPr sz="1875" b="0">
+                <a:solidFill>
+                  <a:srgbClr val="102C32"/>
+                </a:solidFill>
+                <a:latin typeface="Arial"/>
+                <a:ea typeface="Arial"/>
+                <a:cs typeface="Arial"/>
+              </a:rPr>
+              <a:t>Optional visit or</a:t>
+            </a:r>
+          </a:p>
+          <a:p xmlns:a="http://schemas.openxmlformats.org/drawingml/2006/main">
+            <a:pPr>
+              <a:defRPr sz="1875" b="0">
+                <a:solidFill>
+                  <a:srgbClr val="102C32"/>
+                </a:solidFill>
+                <a:latin typeface="Arial"/>
+                <a:ea typeface="Arial"/>
+                <a:cs typeface="Arial"/>
+              </a:defRPr>
+            </a:pPr>
+            <a:r>
+              <a:rPr sz="1875" b="0">
+                <a:solidFill>
+                  <a:srgbClr val="102C32"/>
+                </a:solidFill>
+                <a:latin typeface="Arial"/>
+                <a:ea typeface="Arial"/>
+                <a:cs typeface="Arial"/>
+              </a:rPr>
+              <a:t>test drive</a:t>
             </a:r>
           </a:p>
         </p:txBody>
       </p:sp>
       <p:sp>
         <p:nvSpPr>
-          <p:cNvPr id="22" name="Human review">
+          <p:cNvPr id="22" name="Staff approve any contact">
             <a:extLst xmlns:a="http://schemas.openxmlformats.org/drawingml/2006/main">
               <a:ext uri="{FF2B5EF4-FFF2-40B4-BE49-F238E27FC236}">
-                <a16:creationId xmlns:a16="http://schemas.microsoft.com/office/drawing/2014/main" id="{49FB3105-8DBD-4607-9103-5FD96697B135}"/>
+                <a16:creationId xmlns:a16="http://schemas.microsoft.com/office/drawing/2014/main" id="{A2D8BE75-2077-417A-9748-3675F293F758}"/>
               </a:ext>
             </a:extLst>
           </p:cNvPr>
@@ -9826,8 +9918,8 @@
         </p:nvSpPr>
         <p:spPr>
           <a:xfrm xmlns:a="http://schemas.openxmlformats.org/drawingml/2006/main">
-            <a:off x="8667750" y="4362450"/>
-            <a:ext cx="2895600" cy="400050"/>
+            <a:off x="8667750" y="5114925"/>
+            <a:ext cx="2895600" cy="647700"/>
           </a:xfrm>
           <a:prstGeom xmlns:a="http://schemas.openxmlformats.org/drawingml/2006/main" prst="rect">
             <a:avLst/>
@@ -9842,8 +9934,8 @@
             <a:noAutofit/>
           </a:bodyPr>
           <a:lstStyle xmlns:a="http://schemas.openxmlformats.org/drawingml/2006/main">
-            <a:defPPr algn="l">
-              <a:defRPr sz="2175" b="1">
+            <a:defPPr>
+              <a:defRPr sz="2025" b="1">
                 <a:solidFill>
                   <a:srgbClr val="102C32"/>
                 </a:solidFill>
@@ -9852,8 +9944,8 @@
                 <a:cs typeface="Arial"/>
               </a:defRPr>
             </a:defPPr>
-            <a:lvl1pPr algn="l">
-              <a:defRPr sz="2175" b="1">
+            <a:lvl1pPr>
+              <a:defRPr sz="2025" b="1">
                 <a:solidFill>
                   <a:srgbClr val="102C32"/>
                 </a:solidFill>
@@ -9862,8 +9954,8 @@
                 <a:cs typeface="Arial"/>
               </a:defRPr>
             </a:lvl1pPr>
-            <a:lvl2pPr algn="l">
-              <a:defRPr sz="2175" b="1">
+            <a:lvl2pPr>
+              <a:defRPr sz="2025" b="1">
                 <a:solidFill>
                   <a:srgbClr val="102C32"/>
                 </a:solidFill>
@@ -9872,8 +9964,8 @@
                 <a:cs typeface="Arial"/>
               </a:defRPr>
             </a:lvl2pPr>
-            <a:lvl3pPr algn="l">
-              <a:defRPr sz="2175" b="1">
+            <a:lvl3pPr>
+              <a:defRPr sz="2025" b="1">
                 <a:solidFill>
                   <a:srgbClr val="102C32"/>
                 </a:solidFill>
@@ -9882,8 +9974,8 @@
                 <a:cs typeface="Arial"/>
               </a:defRPr>
             </a:lvl3pPr>
-            <a:lvl4pPr algn="l">
-              <a:defRPr sz="2175" b="1">
+            <a:lvl4pPr>
+              <a:defRPr sz="2025" b="1">
                 <a:solidFill>
                   <a:srgbClr val="102C32"/>
                 </a:solidFill>
@@ -9892,8 +9984,8 @@
                 <a:cs typeface="Arial"/>
               </a:defRPr>
             </a:lvl4pPr>
-            <a:lvl5pPr algn="l">
-              <a:defRPr sz="2175" b="1">
+            <a:lvl5pPr>
+              <a:defRPr sz="2025" b="1">
                 <a:solidFill>
                   <a:srgbClr val="102C32"/>
                 </a:solidFill>
@@ -9902,8 +9994,8 @@
                 <a:cs typeface="Arial"/>
               </a:defRPr>
             </a:lvl5pPr>
-            <a:lvl6pPr algn="l">
-              <a:defRPr sz="2175" b="1">
+            <a:lvl6pPr>
+              <a:defRPr sz="2025" b="1">
                 <a:solidFill>
                   <a:srgbClr val="102C32"/>
                 </a:solidFill>
@@ -9912,8 +10004,8 @@
                 <a:cs typeface="Arial"/>
               </a:defRPr>
             </a:lvl6pPr>
-            <a:lvl7pPr algn="l">
-              <a:defRPr sz="2175" b="1">
+            <a:lvl7pPr>
+              <a:defRPr sz="2025" b="1">
                 <a:solidFill>
                   <a:srgbClr val="102C32"/>
                 </a:solidFill>
@@ -9922,8 +10014,8 @@
                 <a:cs typeface="Arial"/>
               </a:defRPr>
             </a:lvl7pPr>
-            <a:lvl8pPr algn="l">
-              <a:defRPr sz="2175" b="1">
+            <a:lvl8pPr>
+              <a:defRPr sz="2025" b="1">
                 <a:solidFill>
                   <a:srgbClr val="102C32"/>
                 </a:solidFill>
@@ -9932,8 +10024,8 @@
                 <a:cs typeface="Arial"/>
               </a:defRPr>
             </a:lvl8pPr>
-            <a:lvl9pPr algn="l">
-              <a:defRPr sz="2175" b="1">
+            <a:lvl9pPr>
+              <a:defRPr sz="2025" b="1">
                 <a:solidFill>
                   <a:srgbClr val="102C32"/>
                 </a:solidFill>
@@ -9944,8 +10036,8 @@
             </a:lvl9pPr>
           </a:lstStyle>
           <a:p xmlns:a="http://schemas.openxmlformats.org/drawingml/2006/main">
-            <a:pPr algn="l">
-              <a:defRPr sz="2175" b="1">
+            <a:pPr>
+              <a:defRPr sz="2025" b="1">
                 <a:solidFill>
                   <a:srgbClr val="102C32"/>
                 </a:solidFill>
@@ -9955,7 +10047,7 @@
               </a:defRPr>
             </a:pPr>
             <a:r>
-              <a:rPr sz="2175" b="1">
+              <a:rPr sz="2025" b="1">
                 <a:solidFill>
                   <a:srgbClr val="102C32"/>
                 </a:solidFill>
@@ -9963,17 +10055,17 @@
                 <a:ea typeface="Arial"/>
                 <a:cs typeface="Arial"/>
               </a:rPr>
-              <a:t>Human review</a:t>
+              <a:t>Staff approve any contact</a:t>
             </a:r>
           </a:p>
         </p:txBody>
       </p:sp>
       <p:sp>
         <p:nvSpPr>
-          <p:cNvPr id="23" name="Staff confirm the profile&#10;before any contact.">
+          <p:cNvPr id="23" name="Bulk guide CSV: current shortlist, up to 1,000">
             <a:extLst xmlns:a="http://schemas.openxmlformats.org/drawingml/2006/main">
               <a:ext uri="{FF2B5EF4-FFF2-40B4-BE49-F238E27FC236}">
-                <a16:creationId xmlns:a16="http://schemas.microsoft.com/office/drawing/2014/main" id="{41C0C20B-5B8B-4731-BC27-F97BDDACD1A5}"/>
+                <a16:creationId xmlns:a16="http://schemas.microsoft.com/office/drawing/2014/main" id="{6725F949-54B0-49A9-9E2E-319F19831FB9}"/>
               </a:ext>
             </a:extLst>
           </p:cNvPr>
@@ -9984,8 +10076,8 @@
         </p:nvSpPr>
         <p:spPr>
           <a:xfrm xmlns:a="http://schemas.openxmlformats.org/drawingml/2006/main">
-            <a:off x="8667750" y="4924425"/>
-            <a:ext cx="2895600" cy="971550"/>
+            <a:off x="609600" y="5886450"/>
+            <a:ext cx="10972800" cy="409575"/>
           </a:xfrm>
           <a:prstGeom xmlns:a="http://schemas.openxmlformats.org/drawingml/2006/main" prst="rect">
             <a:avLst/>
@@ -10000,100 +10092,100 @@
             <a:noAutofit/>
           </a:bodyPr>
           <a:lstStyle xmlns:a="http://schemas.openxmlformats.org/drawingml/2006/main">
-            <a:defPPr algn="l">
-              <a:defRPr sz="2025" b="0">
-                <a:solidFill>
-                  <a:srgbClr val="102C32"/>
+            <a:defPPr>
+              <a:defRPr sz="1875" b="0">
+                <a:solidFill>
+                  <a:srgbClr val="496168"/>
                 </a:solidFill>
                 <a:latin typeface="Arial"/>
                 <a:ea typeface="Arial"/>
                 <a:cs typeface="Arial"/>
               </a:defRPr>
             </a:defPPr>
-            <a:lvl1pPr algn="l">
-              <a:defRPr sz="2025" b="0">
-                <a:solidFill>
-                  <a:srgbClr val="102C32"/>
+            <a:lvl1pPr>
+              <a:defRPr sz="1875" b="0">
+                <a:solidFill>
+                  <a:srgbClr val="496168"/>
                 </a:solidFill>
                 <a:latin typeface="Arial"/>
                 <a:ea typeface="Arial"/>
                 <a:cs typeface="Arial"/>
               </a:defRPr>
             </a:lvl1pPr>
-            <a:lvl2pPr algn="l">
-              <a:defRPr sz="2025" b="0">
-                <a:solidFill>
-                  <a:srgbClr val="102C32"/>
+            <a:lvl2pPr>
+              <a:defRPr sz="1875" b="0">
+                <a:solidFill>
+                  <a:srgbClr val="496168"/>
                 </a:solidFill>
                 <a:latin typeface="Arial"/>
                 <a:ea typeface="Arial"/>
                 <a:cs typeface="Arial"/>
               </a:defRPr>
             </a:lvl2pPr>
-            <a:lvl3pPr algn="l">
-              <a:defRPr sz="2025" b="0">
-                <a:solidFill>
-                  <a:srgbClr val="102C32"/>
+            <a:lvl3pPr>
+              <a:defRPr sz="1875" b="0">
+                <a:solidFill>
+                  <a:srgbClr val="496168"/>
                 </a:solidFill>
                 <a:latin typeface="Arial"/>
                 <a:ea typeface="Arial"/>
                 <a:cs typeface="Arial"/>
               </a:defRPr>
             </a:lvl3pPr>
-            <a:lvl4pPr algn="l">
-              <a:defRPr sz="2025" b="0">
-                <a:solidFill>
-                  <a:srgbClr val="102C32"/>
+            <a:lvl4pPr>
+              <a:defRPr sz="1875" b="0">
+                <a:solidFill>
+                  <a:srgbClr val="496168"/>
                 </a:solidFill>
                 <a:latin typeface="Arial"/>
                 <a:ea typeface="Arial"/>
                 <a:cs typeface="Arial"/>
               </a:defRPr>
             </a:lvl4pPr>
-            <a:lvl5pPr algn="l">
-              <a:defRPr sz="2025" b="0">
-                <a:solidFill>
-                  <a:srgbClr val="102C32"/>
+            <a:lvl5pPr>
+              <a:defRPr sz="1875" b="0">
+                <a:solidFill>
+                  <a:srgbClr val="496168"/>
                 </a:solidFill>
                 <a:latin typeface="Arial"/>
                 <a:ea typeface="Arial"/>
                 <a:cs typeface="Arial"/>
               </a:defRPr>
             </a:lvl5pPr>
-            <a:lvl6pPr algn="l">
-              <a:defRPr sz="2025" b="0">
-                <a:solidFill>
-                  <a:srgbClr val="102C32"/>
+            <a:lvl6pPr>
+              <a:defRPr sz="1875" b="0">
+                <a:solidFill>
+                  <a:srgbClr val="496168"/>
                 </a:solidFill>
                 <a:latin typeface="Arial"/>
                 <a:ea typeface="Arial"/>
                 <a:cs typeface="Arial"/>
               </a:defRPr>
             </a:lvl6pPr>
-            <a:lvl7pPr algn="l">
-              <a:defRPr sz="2025" b="0">
-                <a:solidFill>
-                  <a:srgbClr val="102C32"/>
+            <a:lvl7pPr>
+              <a:defRPr sz="1875" b="0">
+                <a:solidFill>
+                  <a:srgbClr val="496168"/>
                 </a:solidFill>
                 <a:latin typeface="Arial"/>
                 <a:ea typeface="Arial"/>
                 <a:cs typeface="Arial"/>
               </a:defRPr>
             </a:lvl7pPr>
-            <a:lvl8pPr algn="l">
-              <a:defRPr sz="2025" b="0">
-                <a:solidFill>
-                  <a:srgbClr val="102C32"/>
+            <a:lvl8pPr>
+              <a:defRPr sz="1875" b="0">
+                <a:solidFill>
+                  <a:srgbClr val="496168"/>
                 </a:solidFill>
                 <a:latin typeface="Arial"/>
                 <a:ea typeface="Arial"/>
                 <a:cs typeface="Arial"/>
               </a:defRPr>
             </a:lvl8pPr>
-            <a:lvl9pPr algn="l">
-              <a:defRPr sz="2025" b="0">
-                <a:solidFill>
-                  <a:srgbClr val="102C32"/>
+            <a:lvl9pPr>
+              <a:defRPr sz="1875" b="0">
+                <a:solidFill>
+                  <a:srgbClr val="496168"/>
                 </a:solidFill>
                 <a:latin typeface="Arial"/>
                 <a:ea typeface="Arial"/>
@@ -10102,10 +10194,10 @@
             </a:lvl9pPr>
           </a:lstStyle>
           <a:p xmlns:a="http://schemas.openxmlformats.org/drawingml/2006/main">
-            <a:pPr algn="l">
-              <a:defRPr sz="2025" b="0">
-                <a:solidFill>
-                  <a:srgbClr val="102C32"/>
+            <a:pPr>
+              <a:defRPr sz="1875" b="0">
+                <a:solidFill>
+                  <a:srgbClr val="496168"/>
                 </a:solidFill>
                 <a:latin typeface="Arial"/>
                 <a:ea typeface="Arial"/>
@@ -10113,38 +10205,15 @@
               </a:defRPr>
             </a:pPr>
             <a:r>
-              <a:rPr sz="2025" b="0">
-                <a:solidFill>
-                  <a:srgbClr val="102C32"/>
+              <a:rPr sz="1875" b="0">
+                <a:solidFill>
+                  <a:srgbClr val="496168"/>
                 </a:solidFill>
                 <a:latin typeface="Arial"/>
                 <a:ea typeface="Arial"/>
                 <a:cs typeface="Arial"/>
               </a:rPr>
-              <a:t>Staff confirm the profile</a:t>
-            </a:r>
-          </a:p>
-          <a:p xmlns:a="http://schemas.openxmlformats.org/drawingml/2006/main">
-            <a:pPr algn="l">
-              <a:defRPr sz="2025" b="0">
-                <a:solidFill>
-                  <a:srgbClr val="102C32"/>
-                </a:solidFill>
-                <a:latin typeface="Arial"/>
-                <a:ea typeface="Arial"/>
-                <a:cs typeface="Arial"/>
-              </a:defRPr>
-            </a:pPr>
-            <a:r>
-              <a:rPr sz="2025" b="0">
-                <a:solidFill>
-                  <a:srgbClr val="102C32"/>
-                </a:solidFill>
-                <a:latin typeface="Arial"/>
-                <a:ea typeface="Arial"/>
-                <a:cs typeface="Arial"/>
-              </a:rPr>
-              <a:t>before any contact.</a:t>
+              <a:t>Bulk guide CSV: current shortlist, up to 1,000 profiles per batch</a:t>
             </a:r>
           </a:p>
         </p:txBody>
@@ -10221,6 +10290,7 @@
               </a:defRPr>
             </a:defPPr>
             <a:lvl1pPr>
+              <a:buNone/>
               <a:defRPr sz="3300" b="1">
                 <a:solidFill>
                   <a:srgbClr val="102C32"/>
@@ -10231,6 +10301,7 @@
               </a:defRPr>
             </a:lvl1pPr>
             <a:lvl2pPr>
+              <a:buNone/>
               <a:defRPr sz="3300" b="1">
                 <a:solidFill>
                   <a:srgbClr val="102C32"/>
@@ -10241,6 +10312,7 @@
               </a:defRPr>
             </a:lvl2pPr>
             <a:lvl3pPr>
+              <a:buNone/>
               <a:defRPr sz="3300" b="1">
                 <a:solidFill>
                   <a:srgbClr val="102C32"/>
@@ -10251,6 +10323,7 @@
               </a:defRPr>
             </a:lvl3pPr>
             <a:lvl4pPr>
+              <a:buNone/>
               <a:defRPr sz="3300" b="1">
                 <a:solidFill>
                   <a:srgbClr val="102C32"/>
@@ -10261,6 +10334,7 @@
               </a:defRPr>
             </a:lvl4pPr>
             <a:lvl5pPr>
+              <a:buNone/>
               <a:defRPr sz="3300" b="1">
                 <a:solidFill>
                   <a:srgbClr val="102C32"/>
@@ -10271,6 +10345,7 @@
               </a:defRPr>
             </a:lvl5pPr>
             <a:lvl6pPr>
+              <a:buNone/>
               <a:defRPr sz="3300" b="1">
                 <a:solidFill>
                   <a:srgbClr val="102C32"/>
@@ -10281,6 +10356,7 @@
               </a:defRPr>
             </a:lvl6pPr>
             <a:lvl7pPr>
+              <a:buNone/>
               <a:defRPr sz="3300" b="1">
                 <a:solidFill>
                   <a:srgbClr val="102C32"/>
@@ -10291,6 +10367,7 @@
               </a:defRPr>
             </a:lvl7pPr>
             <a:lvl8pPr>
+              <a:buNone/>
               <a:defRPr sz="3300" b="1">
                 <a:solidFill>
                   <a:srgbClr val="102C32"/>
@@ -10301,6 +10378,7 @@
               </a:defRPr>
             </a:lvl8pPr>
             <a:lvl9pPr>
+              <a:buNone/>
               <a:defRPr sz="3300" b="1">
                 <a:solidFill>
                   <a:srgbClr val="102C32"/>
@@ -10332,7 +10410,7 @@
                 <a:ea typeface="Arial"/>
                 <a:cs typeface="Arial"/>
               </a:rPr>
-              <a:t>Customer details support human review</a:t>
+              <a:t>Staff can prepare an individual conversation</a:t>
             </a:r>
           </a:p>
         </p:txBody>
@@ -10455,10 +10533,10 @@
       </p:sp>
       <p:sp>
         <p:nvSpPr>
-          <p:cNvPr id="10" name="Existing prototype capture">
+          <p:cNvPr id="10" name="Synthetic profile example with an editable dra">
             <a:extLst xmlns:a="http://schemas.openxmlformats.org/drawingml/2006/main">
               <a:ext uri="{FF2B5EF4-FFF2-40B4-BE49-F238E27FC236}">
-                <a16:creationId xmlns:a16="http://schemas.microsoft.com/office/drawing/2014/main" id="{B04357F4-0907-45C3-A632-D0252CE44EBF}"/>
+                <a16:creationId xmlns:a16="http://schemas.microsoft.com/office/drawing/2014/main" id="{98403FBC-38AF-46FF-9528-D5518C8469CE}"/>
               </a:ext>
             </a:extLst>
           </p:cNvPr>
@@ -10469,8 +10547,8 @@
         </p:nvSpPr>
         <p:spPr>
           <a:xfrm xmlns:a="http://schemas.openxmlformats.org/drawingml/2006/main">
-            <a:off x="609600" y="1409700"/>
-            <a:ext cx="4857750" cy="419100"/>
+            <a:off x="609600" y="1371600"/>
+            <a:ext cx="10972800" cy="428625"/>
           </a:xfrm>
           <a:prstGeom xmlns:a="http://schemas.openxmlformats.org/drawingml/2006/main" prst="rect">
             <a:avLst/>
@@ -10485,7 +10563,7 @@
             <a:noAutofit/>
           </a:bodyPr>
           <a:lstStyle xmlns:a="http://schemas.openxmlformats.org/drawingml/2006/main">
-            <a:defPPr algn="l">
+            <a:defPPr>
               <a:defRPr sz="2325" b="1">
                 <a:solidFill>
                   <a:srgbClr val="15866C"/>
@@ -10495,7 +10573,7 @@
                 <a:cs typeface="Arial"/>
               </a:defRPr>
             </a:defPPr>
-            <a:lvl1pPr algn="l">
+            <a:lvl1pPr>
               <a:defRPr sz="2325" b="1">
                 <a:solidFill>
                   <a:srgbClr val="15866C"/>
@@ -10505,7 +10583,7 @@
                 <a:cs typeface="Arial"/>
               </a:defRPr>
             </a:lvl1pPr>
-            <a:lvl2pPr algn="l">
+            <a:lvl2pPr>
               <a:defRPr sz="2325" b="1">
                 <a:solidFill>
                   <a:srgbClr val="15866C"/>
@@ -10515,7 +10593,7 @@
                 <a:cs typeface="Arial"/>
               </a:defRPr>
             </a:lvl2pPr>
-            <a:lvl3pPr algn="l">
+            <a:lvl3pPr>
               <a:defRPr sz="2325" b="1">
                 <a:solidFill>
                   <a:srgbClr val="15866C"/>
@@ -10525,7 +10603,7 @@
                 <a:cs typeface="Arial"/>
               </a:defRPr>
             </a:lvl3pPr>
-            <a:lvl4pPr algn="l">
+            <a:lvl4pPr>
               <a:defRPr sz="2325" b="1">
                 <a:solidFill>
                   <a:srgbClr val="15866C"/>
@@ -10535,7 +10613,7 @@
                 <a:cs typeface="Arial"/>
               </a:defRPr>
             </a:lvl4pPr>
-            <a:lvl5pPr algn="l">
+            <a:lvl5pPr>
               <a:defRPr sz="2325" b="1">
                 <a:solidFill>
                   <a:srgbClr val="15866C"/>
@@ -10545,7 +10623,7 @@
                 <a:cs typeface="Arial"/>
               </a:defRPr>
             </a:lvl5pPr>
-            <a:lvl6pPr algn="l">
+            <a:lvl6pPr>
               <a:defRPr sz="2325" b="1">
                 <a:solidFill>
                   <a:srgbClr val="15866C"/>
@@ -10555,7 +10633,7 @@
                 <a:cs typeface="Arial"/>
               </a:defRPr>
             </a:lvl6pPr>
-            <a:lvl7pPr algn="l">
+            <a:lvl7pPr>
               <a:defRPr sz="2325" b="1">
                 <a:solidFill>
                   <a:srgbClr val="15866C"/>
@@ -10565,7 +10643,7 @@
                 <a:cs typeface="Arial"/>
               </a:defRPr>
             </a:lvl7pPr>
-            <a:lvl8pPr algn="l">
+            <a:lvl8pPr>
               <a:defRPr sz="2325" b="1">
                 <a:solidFill>
                   <a:srgbClr val="15866C"/>
@@ -10575,7 +10653,7 @@
                 <a:cs typeface="Arial"/>
               </a:defRPr>
             </a:lvl8pPr>
-            <a:lvl9pPr algn="l">
+            <a:lvl9pPr>
               <a:defRPr sz="2325" b="1">
                 <a:solidFill>
                   <a:srgbClr val="15866C"/>
@@ -10587,7 +10665,7 @@
             </a:lvl9pPr>
           </a:lstStyle>
           <a:p xmlns:a="http://schemas.openxmlformats.org/drawingml/2006/main">
-            <a:pPr algn="l">
+            <a:pPr>
               <a:defRPr sz="2325" b="1">
                 <a:solidFill>
                   <a:srgbClr val="15866C"/>
@@ -10606,583 +10684,17 @@
                 <a:ea typeface="Arial"/>
                 <a:cs typeface="Arial"/>
               </a:rPr>
-              <a:t>Existing prototype capture</a:t>
-            </a:r>
-          </a:p>
-        </p:txBody>
-      </p:sp>
-      <p:sp>
-        <p:nvSpPr>
-          <p:cNvPr id="11" name="A reviewer can inspect the&#10;recorded profile al">
-            <a:extLst xmlns:a="http://schemas.openxmlformats.org/drawingml/2006/main">
-              <a:ext uri="{FF2B5EF4-FFF2-40B4-BE49-F238E27FC236}">
-                <a16:creationId xmlns:a16="http://schemas.microsoft.com/office/drawing/2014/main" id="{49774007-B1F9-414B-968C-ABAB2880D5AF}"/>
-              </a:ext>
-            </a:extLst>
-          </p:cNvPr>
-          <p:cNvSpPr>
-            <a:spLocks xmlns:a="http://schemas.openxmlformats.org/drawingml/2006/main" noGrp="1"/>
-          </p:cNvSpPr>
-          <p:nvPr/>
-        </p:nvSpPr>
-        <p:spPr>
-          <a:xfrm xmlns:a="http://schemas.openxmlformats.org/drawingml/2006/main">
-            <a:off x="609600" y="2114550"/>
-            <a:ext cx="4857750" cy="1285875"/>
-          </a:xfrm>
-          <a:prstGeom xmlns:a="http://schemas.openxmlformats.org/drawingml/2006/main" prst="rect">
-            <a:avLst/>
-          </a:prstGeom>
-          <a:noFill xmlns:a="http://schemas.openxmlformats.org/drawingml/2006/main"/>
-          <a:ln xmlns:a="http://schemas.openxmlformats.org/drawingml/2006/main" w="0">
-            <a:noFill/>
-          </a:ln>
-        </p:spPr>
-        <p:txBody>
-          <a:bodyPr xmlns:a="http://schemas.openxmlformats.org/drawingml/2006/main" wrap="square" lIns="0" tIns="0" rIns="0" bIns="0" anchor="t">
-            <a:noAutofit/>
-          </a:bodyPr>
-          <a:lstStyle xmlns:a="http://schemas.openxmlformats.org/drawingml/2006/main">
-            <a:defPPr algn="l">
-              <a:defRPr sz="2250" b="0">
-                <a:solidFill>
-                  <a:srgbClr val="102C32"/>
-                </a:solidFill>
-                <a:latin typeface="Arial"/>
-                <a:ea typeface="Arial"/>
-                <a:cs typeface="Arial"/>
-              </a:defRPr>
-            </a:defPPr>
-            <a:lvl1pPr algn="l">
-              <a:defRPr sz="2250" b="0">
-                <a:solidFill>
-                  <a:srgbClr val="102C32"/>
-                </a:solidFill>
-                <a:latin typeface="Arial"/>
-                <a:ea typeface="Arial"/>
-                <a:cs typeface="Arial"/>
-              </a:defRPr>
-            </a:lvl1pPr>
-            <a:lvl2pPr algn="l">
-              <a:defRPr sz="2250" b="0">
-                <a:solidFill>
-                  <a:srgbClr val="102C32"/>
-                </a:solidFill>
-                <a:latin typeface="Arial"/>
-                <a:ea typeface="Arial"/>
-                <a:cs typeface="Arial"/>
-              </a:defRPr>
-            </a:lvl2pPr>
-            <a:lvl3pPr algn="l">
-              <a:defRPr sz="2250" b="0">
-                <a:solidFill>
-                  <a:srgbClr val="102C32"/>
-                </a:solidFill>
-                <a:latin typeface="Arial"/>
-                <a:ea typeface="Arial"/>
-                <a:cs typeface="Arial"/>
-              </a:defRPr>
-            </a:lvl3pPr>
-            <a:lvl4pPr algn="l">
-              <a:defRPr sz="2250" b="0">
-                <a:solidFill>
-                  <a:srgbClr val="102C32"/>
-                </a:solidFill>
-                <a:latin typeface="Arial"/>
-                <a:ea typeface="Arial"/>
-                <a:cs typeface="Arial"/>
-              </a:defRPr>
-            </a:lvl4pPr>
-            <a:lvl5pPr algn="l">
-              <a:defRPr sz="2250" b="0">
-                <a:solidFill>
-                  <a:srgbClr val="102C32"/>
-                </a:solidFill>
-                <a:latin typeface="Arial"/>
-                <a:ea typeface="Arial"/>
-                <a:cs typeface="Arial"/>
-              </a:defRPr>
-            </a:lvl5pPr>
-            <a:lvl6pPr algn="l">
-              <a:defRPr sz="2250" b="0">
-                <a:solidFill>
-                  <a:srgbClr val="102C32"/>
-                </a:solidFill>
-                <a:latin typeface="Arial"/>
-                <a:ea typeface="Arial"/>
-                <a:cs typeface="Arial"/>
-              </a:defRPr>
-            </a:lvl6pPr>
-            <a:lvl7pPr algn="l">
-              <a:defRPr sz="2250" b="0">
-                <a:solidFill>
-                  <a:srgbClr val="102C32"/>
-                </a:solidFill>
-                <a:latin typeface="Arial"/>
-                <a:ea typeface="Arial"/>
-                <a:cs typeface="Arial"/>
-              </a:defRPr>
-            </a:lvl7pPr>
-            <a:lvl8pPr algn="l">
-              <a:defRPr sz="2250" b="0">
-                <a:solidFill>
-                  <a:srgbClr val="102C32"/>
-                </a:solidFill>
-                <a:latin typeface="Arial"/>
-                <a:ea typeface="Arial"/>
-                <a:cs typeface="Arial"/>
-              </a:defRPr>
-            </a:lvl8pPr>
-            <a:lvl9pPr algn="l">
-              <a:defRPr sz="2250" b="0">
-                <a:solidFill>
-                  <a:srgbClr val="102C32"/>
-                </a:solidFill>
-                <a:latin typeface="Arial"/>
-                <a:ea typeface="Arial"/>
-                <a:cs typeface="Arial"/>
-              </a:defRPr>
-            </a:lvl9pPr>
-          </a:lstStyle>
-          <a:p xmlns:a="http://schemas.openxmlformats.org/drawingml/2006/main">
-            <a:pPr algn="l">
-              <a:defRPr sz="2250" b="0">
-                <a:solidFill>
-                  <a:srgbClr val="102C32"/>
-                </a:solidFill>
-                <a:latin typeface="Arial"/>
-                <a:ea typeface="Arial"/>
-                <a:cs typeface="Arial"/>
-              </a:defRPr>
-            </a:pPr>
-            <a:r>
-              <a:rPr sz="2250" b="0">
-                <a:solidFill>
-                  <a:srgbClr val="102C32"/>
-                </a:solidFill>
-                <a:latin typeface="Arial"/>
-                <a:ea typeface="Arial"/>
-                <a:cs typeface="Arial"/>
-              </a:rPr>
-              <a:t>A reviewer can inspect the</a:t>
-            </a:r>
-          </a:p>
-          <a:p xmlns:a="http://schemas.openxmlformats.org/drawingml/2006/main">
-            <a:pPr algn="l">
-              <a:defRPr sz="2250" b="0">
-                <a:solidFill>
-                  <a:srgbClr val="102C32"/>
-                </a:solidFill>
-                <a:latin typeface="Arial"/>
-                <a:ea typeface="Arial"/>
-                <a:cs typeface="Arial"/>
-              </a:defRPr>
-            </a:pPr>
-            <a:r>
-              <a:rPr sz="2250" b="0">
-                <a:solidFill>
-                  <a:srgbClr val="102C32"/>
-                </a:solidFill>
-                <a:latin typeface="Arial"/>
-                <a:ea typeface="Arial"/>
-                <a:cs typeface="Arial"/>
-              </a:rPr>
-              <a:t>recorded profile alongside</a:t>
-            </a:r>
-          </a:p>
-          <a:p xmlns:a="http://schemas.openxmlformats.org/drawingml/2006/main">
-            <a:pPr algn="l">
-              <a:defRPr sz="2250" b="0">
-                <a:solidFill>
-                  <a:srgbClr val="102C32"/>
-                </a:solidFill>
-                <a:latin typeface="Arial"/>
-                <a:ea typeface="Arial"/>
-                <a:cs typeface="Arial"/>
-              </a:defRPr>
-            </a:pPr>
-            <a:r>
-              <a:rPr sz="2250" b="0">
-                <a:solidFill>
-                  <a:srgbClr val="102C32"/>
-                </a:solidFill>
-                <a:latin typeface="Arial"/>
-                <a:ea typeface="Arial"/>
-                <a:cs typeface="Arial"/>
-              </a:rPr>
-              <a:t>questions for a conversation.</a:t>
-            </a:r>
-          </a:p>
-        </p:txBody>
-      </p:sp>
-      <p:sp>
-        <p:nvSpPr>
-          <p:cNvPr id="12" name="Confirm charging access and&#10;travel needs with ">
-            <a:extLst xmlns:a="http://schemas.openxmlformats.org/drawingml/2006/main">
-              <a:ext uri="{FF2B5EF4-FFF2-40B4-BE49-F238E27FC236}">
-                <a16:creationId xmlns:a16="http://schemas.microsoft.com/office/drawing/2014/main" id="{904EB68E-615D-4183-AA14-6BD60DB77D24}"/>
-              </a:ext>
-            </a:extLst>
-          </p:cNvPr>
-          <p:cNvSpPr>
-            <a:spLocks xmlns:a="http://schemas.openxmlformats.org/drawingml/2006/main" noGrp="1"/>
-          </p:cNvSpPr>
-          <p:nvPr/>
-        </p:nvSpPr>
-        <p:spPr>
-          <a:xfrm xmlns:a="http://schemas.openxmlformats.org/drawingml/2006/main">
-            <a:off x="609600" y="3829050"/>
-            <a:ext cx="4857750" cy="1304925"/>
-          </a:xfrm>
-          <a:prstGeom xmlns:a="http://schemas.openxmlformats.org/drawingml/2006/main" prst="rect">
-            <a:avLst/>
-          </a:prstGeom>
-          <a:noFill xmlns:a="http://schemas.openxmlformats.org/drawingml/2006/main"/>
-          <a:ln xmlns:a="http://schemas.openxmlformats.org/drawingml/2006/main" w="0">
-            <a:noFill/>
-          </a:ln>
-        </p:spPr>
-        <p:txBody>
-          <a:bodyPr xmlns:a="http://schemas.openxmlformats.org/drawingml/2006/main" wrap="square" lIns="0" tIns="0" rIns="0" bIns="0" anchor="t">
-            <a:noAutofit/>
-          </a:bodyPr>
-          <a:lstStyle xmlns:a="http://schemas.openxmlformats.org/drawingml/2006/main">
-            <a:defPPr algn="l">
-              <a:defRPr sz="2175" b="0">
-                <a:solidFill>
-                  <a:srgbClr val="102C32"/>
-                </a:solidFill>
-                <a:latin typeface="Arial"/>
-                <a:ea typeface="Arial"/>
-                <a:cs typeface="Arial"/>
-              </a:defRPr>
-            </a:defPPr>
-            <a:lvl1pPr algn="l">
-              <a:defRPr sz="2175" b="0">
-                <a:solidFill>
-                  <a:srgbClr val="102C32"/>
-                </a:solidFill>
-                <a:latin typeface="Arial"/>
-                <a:ea typeface="Arial"/>
-                <a:cs typeface="Arial"/>
-              </a:defRPr>
-            </a:lvl1pPr>
-            <a:lvl2pPr algn="l">
-              <a:defRPr sz="2175" b="0">
-                <a:solidFill>
-                  <a:srgbClr val="102C32"/>
-                </a:solidFill>
-                <a:latin typeface="Arial"/>
-                <a:ea typeface="Arial"/>
-                <a:cs typeface="Arial"/>
-              </a:defRPr>
-            </a:lvl2pPr>
-            <a:lvl3pPr algn="l">
-              <a:defRPr sz="2175" b="0">
-                <a:solidFill>
-                  <a:srgbClr val="102C32"/>
-                </a:solidFill>
-                <a:latin typeface="Arial"/>
-                <a:ea typeface="Arial"/>
-                <a:cs typeface="Arial"/>
-              </a:defRPr>
-            </a:lvl3pPr>
-            <a:lvl4pPr algn="l">
-              <a:defRPr sz="2175" b="0">
-                <a:solidFill>
-                  <a:srgbClr val="102C32"/>
-                </a:solidFill>
-                <a:latin typeface="Arial"/>
-                <a:ea typeface="Arial"/>
-                <a:cs typeface="Arial"/>
-              </a:defRPr>
-            </a:lvl4pPr>
-            <a:lvl5pPr algn="l">
-              <a:defRPr sz="2175" b="0">
-                <a:solidFill>
-                  <a:srgbClr val="102C32"/>
-                </a:solidFill>
-                <a:latin typeface="Arial"/>
-                <a:ea typeface="Arial"/>
-                <a:cs typeface="Arial"/>
-              </a:defRPr>
-            </a:lvl5pPr>
-            <a:lvl6pPr algn="l">
-              <a:defRPr sz="2175" b="0">
-                <a:solidFill>
-                  <a:srgbClr val="102C32"/>
-                </a:solidFill>
-                <a:latin typeface="Arial"/>
-                <a:ea typeface="Arial"/>
-                <a:cs typeface="Arial"/>
-              </a:defRPr>
-            </a:lvl6pPr>
-            <a:lvl7pPr algn="l">
-              <a:defRPr sz="2175" b="0">
-                <a:solidFill>
-                  <a:srgbClr val="102C32"/>
-                </a:solidFill>
-                <a:latin typeface="Arial"/>
-                <a:ea typeface="Arial"/>
-                <a:cs typeface="Arial"/>
-              </a:defRPr>
-            </a:lvl7pPr>
-            <a:lvl8pPr algn="l">
-              <a:defRPr sz="2175" b="0">
-                <a:solidFill>
-                  <a:srgbClr val="102C32"/>
-                </a:solidFill>
-                <a:latin typeface="Arial"/>
-                <a:ea typeface="Arial"/>
-                <a:cs typeface="Arial"/>
-              </a:defRPr>
-            </a:lvl8pPr>
-            <a:lvl9pPr algn="l">
-              <a:defRPr sz="2175" b="0">
-                <a:solidFill>
-                  <a:srgbClr val="102C32"/>
-                </a:solidFill>
-                <a:latin typeface="Arial"/>
-                <a:ea typeface="Arial"/>
-                <a:cs typeface="Arial"/>
-              </a:defRPr>
-            </a:lvl9pPr>
-          </a:lstStyle>
-          <a:p xmlns:a="http://schemas.openxmlformats.org/drawingml/2006/main">
-            <a:pPr algn="l">
-              <a:defRPr sz="2175" b="0">
-                <a:solidFill>
-                  <a:srgbClr val="102C32"/>
-                </a:solidFill>
-                <a:latin typeface="Arial"/>
-                <a:ea typeface="Arial"/>
-                <a:cs typeface="Arial"/>
-              </a:defRPr>
-            </a:pPr>
-            <a:r>
-              <a:rPr sz="2175" b="0">
-                <a:solidFill>
-                  <a:srgbClr val="102C32"/>
-                </a:solidFill>
-                <a:latin typeface="Arial"/>
-                <a:ea typeface="Arial"/>
-                <a:cs typeface="Arial"/>
-              </a:rPr>
-              <a:t>Confirm charging access and</a:t>
-            </a:r>
-          </a:p>
-          <a:p xmlns:a="http://schemas.openxmlformats.org/drawingml/2006/main">
-            <a:pPr algn="l">
-              <a:defRPr sz="2175" b="0">
-                <a:solidFill>
-                  <a:srgbClr val="102C32"/>
-                </a:solidFill>
-                <a:latin typeface="Arial"/>
-                <a:ea typeface="Arial"/>
-                <a:cs typeface="Arial"/>
-              </a:defRPr>
-            </a:pPr>
-            <a:r>
-              <a:rPr sz="2175" b="0">
-                <a:solidFill>
-                  <a:srgbClr val="102C32"/>
-                </a:solidFill>
-                <a:latin typeface="Arial"/>
-                <a:ea typeface="Arial"/>
-                <a:cs typeface="Arial"/>
-              </a:rPr>
-              <a:t>travel needs with the customer.</a:t>
-            </a:r>
-          </a:p>
-          <a:p xmlns:a="http://schemas.openxmlformats.org/drawingml/2006/main">
-            <a:pPr algn="l">
-              <a:defRPr sz="2175" b="0">
-                <a:solidFill>
-                  <a:srgbClr val="102C32"/>
-                </a:solidFill>
-                <a:latin typeface="Arial"/>
-                <a:ea typeface="Arial"/>
-                <a:cs typeface="Arial"/>
-              </a:defRPr>
-            </a:pPr>
-            <a:r>
-              <a:rPr sz="2175" b="0">
-                <a:solidFill>
-                  <a:srgbClr val="102C32"/>
-                </a:solidFill>
-                <a:latin typeface="Arial"/>
-                <a:ea typeface="Arial"/>
-                <a:cs typeface="Arial"/>
-              </a:rPr>
-              <a:t>Recorded fields can be incomplete.</a:t>
-            </a:r>
-          </a:p>
-        </p:txBody>
-      </p:sp>
-      <p:sp>
-        <p:nvSpPr>
-          <p:cNvPr id="13" name="Synthetic profile example">
-            <a:extLst xmlns:a="http://schemas.openxmlformats.org/drawingml/2006/main">
-              <a:ext uri="{FF2B5EF4-FFF2-40B4-BE49-F238E27FC236}">
-                <a16:creationId xmlns:a16="http://schemas.microsoft.com/office/drawing/2014/main" id="{56C156BE-276D-4A4D-9D6A-A07FE81CB6CF}"/>
-              </a:ext>
-            </a:extLst>
-          </p:cNvPr>
-          <p:cNvSpPr>
-            <a:spLocks xmlns:a="http://schemas.openxmlformats.org/drawingml/2006/main" noGrp="1"/>
-          </p:cNvSpPr>
-          <p:nvPr/>
-        </p:nvSpPr>
-        <p:spPr>
-          <a:xfrm xmlns:a="http://schemas.openxmlformats.org/drawingml/2006/main">
-            <a:off x="609600" y="5629275"/>
-            <a:ext cx="4857750" cy="409575"/>
-          </a:xfrm>
-          <a:prstGeom xmlns:a="http://schemas.openxmlformats.org/drawingml/2006/main" prst="rect">
-            <a:avLst/>
-          </a:prstGeom>
-          <a:noFill xmlns:a="http://schemas.openxmlformats.org/drawingml/2006/main"/>
-          <a:ln xmlns:a="http://schemas.openxmlformats.org/drawingml/2006/main" w="0">
-            <a:noFill/>
-          </a:ln>
-        </p:spPr>
-        <p:txBody>
-          <a:bodyPr xmlns:a="http://schemas.openxmlformats.org/drawingml/2006/main" wrap="square" lIns="0" tIns="0" rIns="0" bIns="0" anchor="t">
-            <a:noAutofit/>
-          </a:bodyPr>
-          <a:lstStyle xmlns:a="http://schemas.openxmlformats.org/drawingml/2006/main">
-            <a:defPPr algn="l">
-              <a:defRPr sz="1875" b="0">
-                <a:solidFill>
-                  <a:srgbClr val="496168"/>
-                </a:solidFill>
-                <a:latin typeface="Arial"/>
-                <a:ea typeface="Arial"/>
-                <a:cs typeface="Arial"/>
-              </a:defRPr>
-            </a:defPPr>
-            <a:lvl1pPr algn="l">
-              <a:defRPr sz="1875" b="0">
-                <a:solidFill>
-                  <a:srgbClr val="496168"/>
-                </a:solidFill>
-                <a:latin typeface="Arial"/>
-                <a:ea typeface="Arial"/>
-                <a:cs typeface="Arial"/>
-              </a:defRPr>
-            </a:lvl1pPr>
-            <a:lvl2pPr algn="l">
-              <a:defRPr sz="1875" b="0">
-                <a:solidFill>
-                  <a:srgbClr val="496168"/>
-                </a:solidFill>
-                <a:latin typeface="Arial"/>
-                <a:ea typeface="Arial"/>
-                <a:cs typeface="Arial"/>
-              </a:defRPr>
-            </a:lvl2pPr>
-            <a:lvl3pPr algn="l">
-              <a:defRPr sz="1875" b="0">
-                <a:solidFill>
-                  <a:srgbClr val="496168"/>
-                </a:solidFill>
-                <a:latin typeface="Arial"/>
-                <a:ea typeface="Arial"/>
-                <a:cs typeface="Arial"/>
-              </a:defRPr>
-            </a:lvl3pPr>
-            <a:lvl4pPr algn="l">
-              <a:defRPr sz="1875" b="0">
-                <a:solidFill>
-                  <a:srgbClr val="496168"/>
-                </a:solidFill>
-                <a:latin typeface="Arial"/>
-                <a:ea typeface="Arial"/>
-                <a:cs typeface="Arial"/>
-              </a:defRPr>
-            </a:lvl4pPr>
-            <a:lvl5pPr algn="l">
-              <a:defRPr sz="1875" b="0">
-                <a:solidFill>
-                  <a:srgbClr val="496168"/>
-                </a:solidFill>
-                <a:latin typeface="Arial"/>
-                <a:ea typeface="Arial"/>
-                <a:cs typeface="Arial"/>
-              </a:defRPr>
-            </a:lvl5pPr>
-            <a:lvl6pPr algn="l">
-              <a:defRPr sz="1875" b="0">
-                <a:solidFill>
-                  <a:srgbClr val="496168"/>
-                </a:solidFill>
-                <a:latin typeface="Arial"/>
-                <a:ea typeface="Arial"/>
-                <a:cs typeface="Arial"/>
-              </a:defRPr>
-            </a:lvl6pPr>
-            <a:lvl7pPr algn="l">
-              <a:defRPr sz="1875" b="0">
-                <a:solidFill>
-                  <a:srgbClr val="496168"/>
-                </a:solidFill>
-                <a:latin typeface="Arial"/>
-                <a:ea typeface="Arial"/>
-                <a:cs typeface="Arial"/>
-              </a:defRPr>
-            </a:lvl7pPr>
-            <a:lvl8pPr algn="l">
-              <a:defRPr sz="1875" b="0">
-                <a:solidFill>
-                  <a:srgbClr val="496168"/>
-                </a:solidFill>
-                <a:latin typeface="Arial"/>
-                <a:ea typeface="Arial"/>
-                <a:cs typeface="Arial"/>
-              </a:defRPr>
-            </a:lvl8pPr>
-            <a:lvl9pPr algn="l">
-              <a:defRPr sz="1875" b="0">
-                <a:solidFill>
-                  <a:srgbClr val="496168"/>
-                </a:solidFill>
-                <a:latin typeface="Arial"/>
-                <a:ea typeface="Arial"/>
-                <a:cs typeface="Arial"/>
-              </a:defRPr>
-            </a:lvl9pPr>
-          </a:lstStyle>
-          <a:p xmlns:a="http://schemas.openxmlformats.org/drawingml/2006/main">
-            <a:pPr algn="l">
-              <a:defRPr sz="1875" b="0">
-                <a:solidFill>
-                  <a:srgbClr val="496168"/>
-                </a:solidFill>
-                <a:latin typeface="Arial"/>
-                <a:ea typeface="Arial"/>
-                <a:cs typeface="Arial"/>
-              </a:defRPr>
-            </a:pPr>
-            <a:r>
-              <a:rPr sz="1875" b="0">
-                <a:solidFill>
-                  <a:srgbClr val="496168"/>
-                </a:solidFill>
-                <a:latin typeface="Arial"/>
-                <a:ea typeface="Arial"/>
-                <a:cs typeface="Arial"/>
-              </a:rPr>
-              <a:t>Synthetic profile example</a:t>
+              <a:t>Synthetic profile example with an editable draft</a:t>
             </a:r>
           </a:p>
         </p:txBody>
       </p:sp>
       <p:pic>
         <p:nvPicPr>
-          <p:cNvPr id="14" name="">
+          <p:cNvPr id="11" name="">
             <a:extLst xmlns:a="http://schemas.openxmlformats.org/drawingml/2006/main">
               <a:ext uri="{FF2B5EF4-FFF2-40B4-BE49-F238E27FC236}">
-                <a16:creationId xmlns:a16="http://schemas.microsoft.com/office/drawing/2014/main" id="{ABA84B6D-2A49-40CC-B084-6A446A4C8352}"/>
+                <a16:creationId xmlns:a16="http://schemas.microsoft.com/office/drawing/2014/main" id="{3A0865B5-E9B4-473E-80DD-99F82F4334CB}"/>
               </a:ext>
             </a:extLst>
           </p:cNvPr>
@@ -11192,13 +10704,14 @@
           <p:nvPr/>
         </p:nvPicPr>
         <p:blipFill>
-          <a:blip xmlns:r="http://schemas.openxmlformats.org/officeDocument/2006/relationships" xmlns:a="http://schemas.openxmlformats.org/drawingml/2006/main" r:embed="Rb702a9e609d94aa4"/>
+          <a:blip xmlns:r="http://schemas.openxmlformats.org/officeDocument/2006/relationships" xmlns:a="http://schemas.openxmlformats.org/drawingml/2006/main" r:embed="R6931e79faa124b6c"/>
+          <a:srcRect xmlns:a="http://schemas.openxmlformats.org/drawingml/2006/main" l="5000" t="34167" r="5000" b="0"/>
           <a:stretch xmlns:a="http://schemas.openxmlformats.org/drawingml/2006/main"/>
         </p:blipFill>
         <p:spPr>
           <a:xfrm xmlns:a="http://schemas.openxmlformats.org/drawingml/2006/main">
-            <a:off x="6092794" y="1362075"/>
-            <a:ext cx="5397562" cy="4867275"/>
+            <a:off x="609600" y="1743075"/>
+            <a:ext cx="10972800" cy="4514850"/>
           </a:xfrm>
           <a:prstGeom xmlns:a="http://schemas.openxmlformats.org/drawingml/2006/main" prst="rect">
             <a:avLst/>
@@ -13970,7 +13483,7 @@
           <p:cNvPr id="47" name="planned-feedback-return">
             <a:extLst xmlns:a="http://schemas.openxmlformats.org/drawingml/2006/main">
               <a:ext uri="{FF2B5EF4-FFF2-40B4-BE49-F238E27FC236}">
-                <a16:creationId xmlns:a16="http://schemas.microsoft.com/office/drawing/2014/main" id="{440C7808-75CD-4E69-BD6C-34B058522D76}"/>
+                <a16:creationId xmlns:a16="http://schemas.microsoft.com/office/drawing/2014/main" id="{0F328F8C-C9AE-42C2-9BD2-E5FF45BDC648}"/>
               </a:ext>
             </a:extLst>
           </p:cNvPr>
@@ -14002,7 +13515,7 @@
           <p:cNvPr id="44" name="">
             <a:extLst xmlns:a="http://schemas.openxmlformats.org/drawingml/2006/main">
               <a:ext uri="{FF2B5EF4-FFF2-40B4-BE49-F238E27FC236}">
-                <a16:creationId xmlns:a16="http://schemas.microsoft.com/office/drawing/2014/main" id="{444E0890-4D24-4BD8-BE83-7F8677C0CD48}"/>
+                <a16:creationId xmlns:a16="http://schemas.microsoft.com/office/drawing/2014/main" id="{0085752E-EB7D-450C-8DF6-E5E9F3C4DC59}"/>
               </a:ext>
             </a:extLst>
           </p:cNvPr>
@@ -14034,7 +13547,7 @@
           <p:cNvPr id="43" name="">
             <a:extLst xmlns:a="http://schemas.openxmlformats.org/drawingml/2006/main">
               <a:ext uri="{FF2B5EF4-FFF2-40B4-BE49-F238E27FC236}">
-                <a16:creationId xmlns:a16="http://schemas.microsoft.com/office/drawing/2014/main" id="{1D2AC13A-6D3D-4A3A-905D-1DD1FE3AC645}"/>
+                <a16:creationId xmlns:a16="http://schemas.microsoft.com/office/drawing/2014/main" id="{055136BB-9578-4B2A-B246-0DDE1E8C365A}"/>
               </a:ext>
             </a:extLst>
           </p:cNvPr>
@@ -14066,7 +13579,7 @@
           <p:cNvPr id="42" name="">
             <a:extLst xmlns:a="http://schemas.openxmlformats.org/drawingml/2006/main">
               <a:ext uri="{FF2B5EF4-FFF2-40B4-BE49-F238E27FC236}">
-                <a16:creationId xmlns:a16="http://schemas.microsoft.com/office/drawing/2014/main" id="{8A09D808-97FD-4498-B560-E576F3EEE6BB}"/>
+                <a16:creationId xmlns:a16="http://schemas.microsoft.com/office/drawing/2014/main" id="{32A1E03E-4521-4778-8E30-7C3A57824EAA}"/>
               </a:ext>
             </a:extLst>
           </p:cNvPr>
@@ -14098,7 +13611,7 @@
           <p:cNvPr id="41" name="">
             <a:extLst xmlns:a="http://schemas.openxmlformats.org/drawingml/2006/main">
               <a:ext uri="{FF2B5EF4-FFF2-40B4-BE49-F238E27FC236}">
-                <a16:creationId xmlns:a16="http://schemas.microsoft.com/office/drawing/2014/main" id="{72855D8A-4F6F-45CA-AA1A-0B24B0A6C6AA}"/>
+                <a16:creationId xmlns:a16="http://schemas.microsoft.com/office/drawing/2014/main" id="{7C11BB88-6609-49E5-9A59-E2F4E341B129}"/>
               </a:ext>
             </a:extLst>
           </p:cNvPr>
@@ -14130,7 +13643,7 @@
           <p:cNvPr id="40" name="">
             <a:extLst xmlns:a="http://schemas.openxmlformats.org/drawingml/2006/main">
               <a:ext uri="{FF2B5EF4-FFF2-40B4-BE49-F238E27FC236}">
-                <a16:creationId xmlns:a16="http://schemas.microsoft.com/office/drawing/2014/main" id="{0C4CB3D4-2FFF-4466-8080-6950B34AC88C}"/>
+                <a16:creationId xmlns:a16="http://schemas.microsoft.com/office/drawing/2014/main" id="{B5E02434-7FB6-434E-B4E9-BD0306608AB5}"/>
               </a:ext>
             </a:extLst>
           </p:cNvPr>
@@ -14162,7 +13675,7 @@
           <p:cNvPr id="39" name="">
             <a:extLst xmlns:a="http://schemas.openxmlformats.org/drawingml/2006/main">
               <a:ext uri="{FF2B5EF4-FFF2-40B4-BE49-F238E27FC236}">
-                <a16:creationId xmlns:a16="http://schemas.microsoft.com/office/drawing/2014/main" id="{126B507E-2210-48DE-BAE5-033AD1DB3163}"/>
+                <a16:creationId xmlns:a16="http://schemas.microsoft.com/office/drawing/2014/main" id="{869782CF-4091-4AED-8637-326704F226C3}"/>
               </a:ext>
             </a:extLst>
           </p:cNvPr>
@@ -14194,7 +13707,7 @@
           <p:cNvPr id="38" name="">
             <a:extLst xmlns:a="http://schemas.openxmlformats.org/drawingml/2006/main">
               <a:ext uri="{FF2B5EF4-FFF2-40B4-BE49-F238E27FC236}">
-                <a16:creationId xmlns:a16="http://schemas.microsoft.com/office/drawing/2014/main" id="{6CE9D659-28D4-42CD-805D-E2027796A32F}"/>
+                <a16:creationId xmlns:a16="http://schemas.microsoft.com/office/drawing/2014/main" id="{308DBD70-49AA-4DF9-B577-EE067D8FC6AB}"/>
               </a:ext>
             </a:extLst>
           </p:cNvPr>
@@ -16864,7 +16377,7 @@
                 <a:ea typeface="Arial"/>
                 <a:cs typeface="Arial"/>
               </a:rPr>
-              <a:t>The current tool ends with a reviewed shortlist and CSV export</a:t>
+              <a:t>The tool supports staff review and downloadable conversation guides</a:t>
             </a:r>
           </a:p>
         </p:txBody>
@@ -17080,6 +16593,7 @@
               </a:defRPr>
             </a:defPPr>
             <a:lvl1pPr algn="ctr">
+              <a:buNone/>
               <a:defRPr sz="1725">
                 <a:solidFill>
                   <a:srgbClr val="496168"/>
@@ -17090,6 +16604,7 @@
               </a:defRPr>
             </a:lvl1pPr>
             <a:lvl2pPr algn="ctr">
+              <a:buNone/>
               <a:defRPr sz="1725">
                 <a:solidFill>
                   <a:srgbClr val="496168"/>
@@ -17100,6 +16615,7 @@
               </a:defRPr>
             </a:lvl2pPr>
             <a:lvl3pPr algn="ctr">
+              <a:buNone/>
               <a:defRPr sz="1725">
                 <a:solidFill>
                   <a:srgbClr val="496168"/>
@@ -17110,6 +16626,7 @@
               </a:defRPr>
             </a:lvl3pPr>
             <a:lvl4pPr algn="ctr">
+              <a:buNone/>
               <a:defRPr sz="1725">
                 <a:solidFill>
                   <a:srgbClr val="496168"/>
@@ -17120,6 +16637,7 @@
               </a:defRPr>
             </a:lvl4pPr>
             <a:lvl5pPr algn="ctr">
+              <a:buNone/>
               <a:defRPr sz="1725">
                 <a:solidFill>
                   <a:srgbClr val="496168"/>
@@ -17130,6 +16648,7 @@
               </a:defRPr>
             </a:lvl5pPr>
             <a:lvl6pPr algn="ctr">
+              <a:buNone/>
               <a:defRPr sz="1725">
                 <a:solidFill>
                   <a:srgbClr val="496168"/>
@@ -17140,6 +16659,7 @@
               </a:defRPr>
             </a:lvl6pPr>
             <a:lvl7pPr algn="ctr">
+              <a:buNone/>
               <a:defRPr sz="1725">
                 <a:solidFill>
                   <a:srgbClr val="496168"/>
@@ -17150,6 +16670,7 @@
               </a:defRPr>
             </a:lvl7pPr>
             <a:lvl8pPr algn="ctr">
+              <a:buNone/>
               <a:defRPr sz="1725">
                 <a:solidFill>
                   <a:srgbClr val="496168"/>
@@ -17160,6 +16681,7 @@
               </a:defRPr>
             </a:lvl8pPr>
             <a:lvl9pPr algn="ctr">
+              <a:buNone/>
               <a:defRPr sz="1725">
                 <a:solidFill>
                   <a:srgbClr val="496168"/>
@@ -17172,6 +16694,7 @@
           </a:lstStyle>
           <a:p xmlns:a="http://schemas.openxmlformats.org/drawingml/2006/main">
             <a:pPr algn="ctr">
+              <a:buNone/>
               <a:defRPr sz="1725">
                 <a:solidFill>
                   <a:srgbClr val="496168"/>

</xml_diff>